<commit_message>
PPT: regenerate as technical 8-slide deck (problem, architecture, deliverables, hardening+metrics, roadmap, demo runbook)
</commit_message>
<xml_diff>
--- a/ppt/SIH_Command_Center.pptx
+++ b/ppt/SIH_Command_Center.pptx
@@ -14,7 +14,7 @@
     <p:sldId id="262" r:id="rId13"/>
     <p:sldId id="263" r:id="rId14"/>
   </p:sldIdLst>
-  <p:sldSz cx="12192000" cy="6858000" type="screen4x3"/>
+  <p:sldSz cx="12191695" cy="6858000" type="screen4x3"/>
   <p:notesSz cx="6858000" cy="9144000"/>
   <p:defaultTextStyle>
     <a:defPPr>
@@ -3097,52 +3097,138 @@
       <p:grpSpPr/>
       <p:sp>
         <p:nvSpPr>
-          <p:cNvPr id="2" name="Title 1"/>
-          <p:cNvSpPr>
-            <a:spLocks noGrp="1"/>
-          </p:cNvSpPr>
-          <p:nvPr>
-            <p:ph type="title"/>
-          </p:nvPr>
-        </p:nvSpPr>
-        <p:spPr/>
-        <p:txBody>
-          <a:bodyPr/>
-          <a:lstStyle/>
-          <a:p>
-            <a:r>
-              <a:t>SIH Command Center</a:t>
-            </a:r>
-          </a:p>
-        </p:txBody>
-      </p:sp>
-      <p:sp>
-        <p:nvSpPr>
-          <p:cNvPr id="3" name="Content Placeholder 2"/>
-          <p:cNvSpPr>
-            <a:spLocks noGrp="1"/>
-          </p:cNvSpPr>
-          <p:nvPr>
-            <p:ph idx="1"/>
-          </p:nvPr>
-        </p:nvSpPr>
-        <p:spPr/>
-        <p:txBody>
-          <a:bodyPr/>
-          <a:lstStyle/>
-          <a:p>
-            <a:r>
-              <a:t>Hackathon Team &amp; Deliverable Tracking (PBL 14)</a:t>
-            </a:r>
-          </a:p>
-          <a:p>
-            <a:r>
-              <a:t>Woxsen University | Full Stack Development</a:t>
-            </a:r>
-          </a:p>
-          <a:p>
-            <a:r>
-              <a:t>Team: full-stack lead, frontend, backend, QA</a:t>
+          <p:cNvPr id="2" name="Rectangle 1"/>
+          <p:cNvSpPr/>
+          <p:nvPr/>
+        </p:nvSpPr>
+        <p:spPr>
+          <a:xfrm>
+            <a:off x="0" y="0"/>
+            <a:ext cx="12191695" cy="6858000"/>
+          </a:xfrm>
+          <a:prstGeom prst="rect">
+            <a:avLst/>
+          </a:prstGeom>
+          <a:solidFill>
+            <a:srgbClr val="0F172A"/>
+          </a:solidFill>
+          <a:ln>
+            <a:noFill/>
+          </a:ln>
+        </p:spPr>
+        <p:style>
+          <a:lnRef idx="1">
+            <a:schemeClr val="accent1"/>
+          </a:lnRef>
+          <a:fillRef idx="3">
+            <a:schemeClr val="accent1"/>
+          </a:fillRef>
+          <a:effectRef idx="2">
+            <a:schemeClr val="accent1"/>
+          </a:effectRef>
+          <a:fontRef idx="minor">
+            <a:schemeClr val="lt1"/>
+          </a:fontRef>
+        </p:style>
+        <p:txBody>
+          <a:bodyPr rtlCol="0" anchor="ctr"/>
+          <a:lstStyle/>
+          <a:p>
+            <a:pPr algn="ctr"/>
+          </a:p>
+        </p:txBody>
+      </p:sp>
+      <p:sp>
+        <p:nvSpPr>
+          <p:cNvPr id="3" name="TextBox 2"/>
+          <p:cNvSpPr txBox="1"/>
+          <p:nvPr/>
+        </p:nvSpPr>
+        <p:spPr>
+          <a:xfrm>
+            <a:off x="914400" y="1280160"/>
+            <a:ext cx="10332720" cy="4389120"/>
+          </a:xfrm>
+          <a:prstGeom prst="rect">
+            <a:avLst/>
+          </a:prstGeom>
+          <a:noFill/>
+        </p:spPr>
+        <p:txBody>
+          <a:bodyPr wrap="square">
+            <a:spAutoFit/>
+          </a:bodyPr>
+          <a:lstStyle/>
+          <a:p>
+            <a:pPr>
+              <a:defRPr sz="1400" b="1">
+                <a:solidFill>
+                  <a:srgbClr val="0EA5E9"/>
+                </a:solidFill>
+              </a:defRPr>
+            </a:pPr>
+            <a:r>
+              <a:t>SMART INDIA HACKATHON 2026 | COMMAND CENTER</a:t>
+            </a:r>
+          </a:p>
+          <a:p>
+            <a:pPr>
+              <a:spcBef>
+                <a:spcPts val="800"/>
+              </a:spcBef>
+              <a:defRPr sz="3600" b="1">
+                <a:solidFill>
+                  <a:srgbClr val="F8FAFC"/>
+                </a:solidFill>
+              </a:defRPr>
+            </a:pPr>
+            <a:r>
+              <a:t>Centralised SPOC Operations &amp; Deliverable Engine</a:t>
+            </a:r>
+          </a:p>
+          <a:p>
+            <a:pPr>
+              <a:spcBef>
+                <a:spcPts val="1200"/>
+              </a:spcBef>
+              <a:defRPr sz="1400">
+                <a:solidFill>
+                  <a:srgbClr val="94A3B8"/>
+                </a:solidFill>
+              </a:defRPr>
+            </a:pPr>
+            <a:r>
+              <a:t>Production-grade MERN architecture - Hardened validation - Stress-tested concurrency - Zero-loss demo mode</a:t>
+            </a:r>
+          </a:p>
+          <a:p>
+            <a:pPr>
+              <a:spcBef>
+                <a:spcPts val="2800"/>
+              </a:spcBef>
+              <a:defRPr sz="1300" b="1">
+                <a:solidFill>
+                  <a:srgbClr val="2563EB"/>
+                </a:solidFill>
+              </a:defRPr>
+            </a:pPr>
+            <a:r>
+              <a:t>Woxsen University | B.Tech CSE SEM 5 | Full Stack Development (24TU05MJC1)</a:t>
+            </a:r>
+          </a:p>
+          <a:p>
+            <a:pPr>
+              <a:spcBef>
+                <a:spcPts val="600"/>
+              </a:spcBef>
+              <a:defRPr sz="1200">
+                <a:solidFill>
+                  <a:srgbClr val="F8FAFC"/>
+                </a:solidFill>
+              </a:defRPr>
+            </a:pPr>
+            <a:r>
+              <a:t>Team of 4: Lead Integrator - Frontend Engineer - Backend Engineer - QA &amp; Reliability Lead</a:t>
             </a:r>
           </a:p>
         </p:txBody>
@@ -3167,62 +3253,483 @@
       <p:grpSpPr/>
       <p:sp>
         <p:nvSpPr>
-          <p:cNvPr id="2" name="Title 1"/>
-          <p:cNvSpPr>
-            <a:spLocks noGrp="1"/>
-          </p:cNvSpPr>
-          <p:nvPr>
-            <p:ph type="title"/>
-          </p:nvPr>
-        </p:nvSpPr>
-        <p:spPr/>
-        <p:txBody>
-          <a:bodyPr/>
-          <a:lstStyle/>
-          <a:p>
-            <a:r>
-              <a:t>Problem</a:t>
-            </a:r>
-          </a:p>
-        </p:txBody>
-      </p:sp>
-      <p:sp>
-        <p:nvSpPr>
-          <p:cNvPr id="3" name="Content Placeholder 2"/>
-          <p:cNvSpPr>
-            <a:spLocks noGrp="1"/>
-          </p:cNvSpPr>
-          <p:nvPr>
-            <p:ph idx="1"/>
-          </p:nvPr>
-        </p:nvSpPr>
-        <p:spPr/>
-        <p:txBody>
-          <a:bodyPr/>
-          <a:lstStyle/>
-          <a:p>
-            <a:r>
-              <a:t>SPOC tracks SIH teams in sheets + emails.</a:t>
-            </a:r>
-          </a:p>
-          <a:p>
-            <a:r>
-              <a:t>- Invalid teams found too late</a:t>
-            </a:r>
-          </a:p>
-          <a:p>
-            <a:r>
-              <a:t>- Same PS picked twice</a:t>
-            </a:r>
-          </a:p>
-          <a:p>
-            <a:r>
-              <a:t>- Uneven mentor load</a:t>
-            </a:r>
-          </a:p>
-          <a:p>
-            <a:r>
-              <a:t>- Deliverables chased on WhatsApp</a:t>
+          <p:cNvPr id="2" name="TextBox 1"/>
+          <p:cNvSpPr txBox="1"/>
+          <p:nvPr/>
+        </p:nvSpPr>
+        <p:spPr>
+          <a:xfrm>
+            <a:off x="731520" y="320040"/>
+            <a:ext cx="10698480" cy="320040"/>
+          </a:xfrm>
+          <a:prstGeom prst="rect">
+            <a:avLst/>
+          </a:prstGeom>
+          <a:noFill/>
+        </p:spPr>
+        <p:txBody>
+          <a:bodyPr wrap="none">
+            <a:spAutoFit/>
+          </a:bodyPr>
+          <a:lstStyle/>
+          <a:p>
+            <a:pPr>
+              <a:defRPr sz="1000" b="1">
+                <a:solidFill>
+                  <a:srgbClr val="2563EB"/>
+                </a:solidFill>
+              </a:defRPr>
+            </a:pPr>
+            <a:r>
+              <a:t>SIH COMMAND CENTER | PBL 14</a:t>
+            </a:r>
+          </a:p>
+        </p:txBody>
+      </p:sp>
+      <p:sp>
+        <p:nvSpPr>
+          <p:cNvPr id="3" name="TextBox 2"/>
+          <p:cNvSpPr txBox="1"/>
+          <p:nvPr/>
+        </p:nvSpPr>
+        <p:spPr>
+          <a:xfrm>
+            <a:off x="731520" y="621792"/>
+            <a:ext cx="10698480" cy="640080"/>
+          </a:xfrm>
+          <a:prstGeom prst="rect">
+            <a:avLst/>
+          </a:prstGeom>
+          <a:noFill/>
+        </p:spPr>
+        <p:txBody>
+          <a:bodyPr wrap="none">
+            <a:spAutoFit/>
+          </a:bodyPr>
+          <a:lstStyle/>
+          <a:p>
+            <a:pPr>
+              <a:defRPr sz="2200" b="1">
+                <a:solidFill>
+                  <a:srgbClr val="0F172A"/>
+                </a:solidFill>
+              </a:defRPr>
+            </a:pPr>
+            <a:r>
+              <a:t>The SPOC Operational Bottleneck &amp; Technical Objectives</a:t>
+            </a:r>
+          </a:p>
+        </p:txBody>
+      </p:sp>
+      <p:sp>
+        <p:nvSpPr>
+          <p:cNvPr id="4" name="Rounded Rectangle 3"/>
+          <p:cNvSpPr/>
+          <p:nvPr/>
+        </p:nvSpPr>
+        <p:spPr>
+          <a:xfrm>
+            <a:off x="731520" y="1371600"/>
+            <a:ext cx="5120640" cy="4937760"/>
+          </a:xfrm>
+          <a:prstGeom prst="roundRect">
+            <a:avLst/>
+          </a:prstGeom>
+          <a:solidFill>
+            <a:srgbClr val="FFFFFF"/>
+          </a:solidFill>
+          <a:ln w="12700">
+            <a:solidFill>
+              <a:srgbClr val="E2E8F0"/>
+            </a:solidFill>
+          </a:ln>
+        </p:spPr>
+        <p:style>
+          <a:lnRef idx="1">
+            <a:schemeClr val="accent1"/>
+          </a:lnRef>
+          <a:fillRef idx="3">
+            <a:schemeClr val="accent1"/>
+          </a:fillRef>
+          <a:effectRef idx="2">
+            <a:schemeClr val="accent1"/>
+          </a:effectRef>
+          <a:fontRef idx="minor">
+            <a:schemeClr val="lt1"/>
+          </a:fontRef>
+        </p:style>
+        <p:txBody>
+          <a:bodyPr rtlCol="0" anchor="ctr"/>
+          <a:lstStyle/>
+          <a:p>
+            <a:pPr algn="ctr"/>
+          </a:p>
+        </p:txBody>
+      </p:sp>
+      <p:sp>
+        <p:nvSpPr>
+          <p:cNvPr id="5" name="TextBox 4"/>
+          <p:cNvSpPr txBox="1"/>
+          <p:nvPr/>
+        </p:nvSpPr>
+        <p:spPr>
+          <a:xfrm>
+            <a:off x="914400" y="1508760"/>
+            <a:ext cx="4754880" cy="411480"/>
+          </a:xfrm>
+          <a:prstGeom prst="rect">
+            <a:avLst/>
+          </a:prstGeom>
+          <a:noFill/>
+        </p:spPr>
+        <p:txBody>
+          <a:bodyPr wrap="none">
+            <a:spAutoFit/>
+          </a:bodyPr>
+          <a:lstStyle/>
+          <a:p>
+            <a:pPr>
+              <a:defRPr sz="1300" b="1">
+                <a:solidFill>
+                  <a:srgbClr val="0F172A"/>
+                </a:solidFill>
+              </a:defRPr>
+            </a:pPr>
+            <a:r>
+              <a:t>Current Failure Modes (Spreadsheet Hell)</a:t>
+            </a:r>
+          </a:p>
+        </p:txBody>
+      </p:sp>
+      <p:sp>
+        <p:nvSpPr>
+          <p:cNvPr id="6" name="TextBox 5"/>
+          <p:cNvSpPr txBox="1"/>
+          <p:nvPr/>
+        </p:nvSpPr>
+        <p:spPr>
+          <a:xfrm>
+            <a:off x="914400" y="1965960"/>
+            <a:ext cx="4754880" cy="4206240"/>
+          </a:xfrm>
+          <a:prstGeom prst="rect">
+            <a:avLst/>
+          </a:prstGeom>
+          <a:noFill/>
+        </p:spPr>
+        <p:txBody>
+          <a:bodyPr wrap="square">
+            <a:spAutoFit/>
+          </a:bodyPr>
+          <a:lstStyle/>
+          <a:p>
+            <a:pPr>
+              <a:spcAft>
+                <a:spcPts val="800"/>
+              </a:spcAft>
+              <a:defRPr b="1" sz="1100">
+                <a:solidFill>
+                  <a:srgbClr val="DC2626"/>
+                </a:solidFill>
+              </a:defRPr>
+            </a:pPr>
+            <a:r>
+              <a:t>- Silent Composition Violations: </a:t>
+            </a:r>
+            <a:r>
+              <a:rPr b="0">
+                <a:solidFill>
+                  <a:srgbClr val="334155"/>
+                </a:solidFill>
+              </a:rPr>
+              <a:t>SIH needs 6 members with 1+ female. Excel cannot enforce atomic pre-commit validation.</a:t>
+            </a:r>
+          </a:p>
+          <a:p>
+            <a:pPr>
+              <a:spcAft>
+                <a:spcPts val="800"/>
+              </a:spcAft>
+              <a:defRPr b="1" sz="1100">
+                <a:solidFill>
+                  <a:srgbClr val="DC2626"/>
+                </a:solidFill>
+              </a:defRPr>
+            </a:pPr>
+            <a:r>
+              <a:t>- Problem Statement Clashing: </a:t>
+            </a:r>
+            <a:r>
+              <a:rPr b="0">
+                <a:solidFill>
+                  <a:srgbClr val="334155"/>
+                </a:solidFill>
+              </a:rPr>
+              <a:t>Duplicates allocated across silos with no shared real-time uniqueness constraint.</a:t>
+            </a:r>
+          </a:p>
+          <a:p>
+            <a:pPr>
+              <a:spcAft>
+                <a:spcPts val="800"/>
+              </a:spcAft>
+              <a:defRPr b="1" sz="1100">
+                <a:solidFill>
+                  <a:srgbClr val="DC2626"/>
+                </a:solidFill>
+              </a:defRPr>
+            </a:pPr>
+            <a:r>
+              <a:t>- Unbalanced Mentor Saturation: </a:t>
+            </a:r>
+            <a:r>
+              <a:rPr b="0">
+                <a:solidFill>
+                  <a:srgbClr val="334155"/>
+                </a:solidFill>
+              </a:rPr>
+              <a:t>Mentors exceed bandwidth while others idle; load tracking is fully manual.</a:t>
+            </a:r>
+          </a:p>
+          <a:p>
+            <a:pPr>
+              <a:spcAft>
+                <a:spcPts val="800"/>
+              </a:spcAft>
+              <a:defRPr b="1" sz="1100">
+                <a:solidFill>
+                  <a:srgbClr val="DC2626"/>
+                </a:solidFill>
+              </a:defRPr>
+            </a:pPr>
+            <a:r>
+              <a:t>- Unquantified Readiness: </a:t>
+            </a:r>
+            <a:r>
+              <a:rPr b="0">
+                <a:solidFill>
+                  <a:srgbClr val="334155"/>
+                </a:solidFill>
+              </a:rPr>
+              <a:t>No continuous score (GitHub, PPT, video, report); SPOC inspects each Drive manually.</a:t>
+            </a:r>
+          </a:p>
+        </p:txBody>
+      </p:sp>
+      <p:sp>
+        <p:nvSpPr>
+          <p:cNvPr id="7" name="Rounded Rectangle 6"/>
+          <p:cNvSpPr/>
+          <p:nvPr/>
+        </p:nvSpPr>
+        <p:spPr>
+          <a:xfrm>
+            <a:off x="6217920" y="1371600"/>
+            <a:ext cx="5212080" cy="4937760"/>
+          </a:xfrm>
+          <a:prstGeom prst="roundRect">
+            <a:avLst/>
+          </a:prstGeom>
+          <a:solidFill>
+            <a:srgbClr val="FFFFFF"/>
+          </a:solidFill>
+          <a:ln w="12700">
+            <a:solidFill>
+              <a:srgbClr val="E2E8F0"/>
+            </a:solidFill>
+          </a:ln>
+        </p:spPr>
+        <p:style>
+          <a:lnRef idx="1">
+            <a:schemeClr val="accent1"/>
+          </a:lnRef>
+          <a:fillRef idx="3">
+            <a:schemeClr val="accent1"/>
+          </a:fillRef>
+          <a:effectRef idx="2">
+            <a:schemeClr val="accent1"/>
+          </a:effectRef>
+          <a:fontRef idx="minor">
+            <a:schemeClr val="lt1"/>
+          </a:fontRef>
+        </p:style>
+        <p:txBody>
+          <a:bodyPr rtlCol="0" anchor="ctr"/>
+          <a:lstStyle/>
+          <a:p>
+            <a:pPr algn="ctr"/>
+          </a:p>
+        </p:txBody>
+      </p:sp>
+      <p:sp>
+        <p:nvSpPr>
+          <p:cNvPr id="8" name="TextBox 7"/>
+          <p:cNvSpPr txBox="1"/>
+          <p:nvPr/>
+        </p:nvSpPr>
+        <p:spPr>
+          <a:xfrm>
+            <a:off x="6400800" y="1508760"/>
+            <a:ext cx="4846320" cy="411480"/>
+          </a:xfrm>
+          <a:prstGeom prst="rect">
+            <a:avLst/>
+          </a:prstGeom>
+          <a:noFill/>
+        </p:spPr>
+        <p:txBody>
+          <a:bodyPr wrap="none">
+            <a:spAutoFit/>
+          </a:bodyPr>
+          <a:lstStyle/>
+          <a:p>
+            <a:pPr>
+              <a:defRPr sz="1300" b="1">
+                <a:solidFill>
+                  <a:srgbClr val="0F172A"/>
+                </a:solidFill>
+              </a:defRPr>
+            </a:pPr>
+            <a:r>
+              <a:t>System Requirements &amp; Design Guarantees</a:t>
+            </a:r>
+          </a:p>
+        </p:txBody>
+      </p:sp>
+      <p:sp>
+        <p:nvSpPr>
+          <p:cNvPr id="9" name="TextBox 8"/>
+          <p:cNvSpPr txBox="1"/>
+          <p:nvPr/>
+        </p:nvSpPr>
+        <p:spPr>
+          <a:xfrm>
+            <a:off x="6400800" y="1965960"/>
+            <a:ext cx="4846320" cy="4206240"/>
+          </a:xfrm>
+          <a:prstGeom prst="rect">
+            <a:avLst/>
+          </a:prstGeom>
+          <a:noFill/>
+        </p:spPr>
+        <p:txBody>
+          <a:bodyPr wrap="square">
+            <a:spAutoFit/>
+          </a:bodyPr>
+          <a:lstStyle/>
+          <a:p>
+            <a:pPr>
+              <a:spcAft>
+                <a:spcPts val="800"/>
+              </a:spcAft>
+              <a:defRPr b="1" sz="1100">
+                <a:solidFill>
+                  <a:srgbClr val="16A34A"/>
+                </a:solidFill>
+              </a:defRPr>
+            </a:pPr>
+            <a:r>
+              <a:t>+ Atomic Hard-Blocking Validation: </a:t>
+            </a:r>
+            <a:r>
+              <a:rPr b="0">
+                <a:solidFill>
+                  <a:srgbClr val="334155"/>
+                </a:solidFill>
+              </a:rPr>
+              <a:t>HTTP 400 rejection of bad rosters before persistence.</a:t>
+            </a:r>
+          </a:p>
+          <a:p>
+            <a:pPr>
+              <a:spcAft>
+                <a:spcPts val="800"/>
+              </a:spcAft>
+              <a:defRPr b="1" sz="1100">
+                <a:solidFill>
+                  <a:srgbClr val="16A34A"/>
+                </a:solidFill>
+              </a:defRPr>
+            </a:pPr>
+            <a:r>
+              <a:t>+ Real-time Duplicate Prevention: </a:t>
+            </a:r>
+            <a:r>
+              <a:rPr b="0">
+                <a:solidFill>
+                  <a:srgbClr val="334155"/>
+                </a:solidFill>
+              </a:rPr>
+              <a:t>Unique lock per PS id with explicit SPOC override flag.</a:t>
+            </a:r>
+          </a:p>
+          <a:p>
+            <a:pPr>
+              <a:spcAft>
+                <a:spcPts val="800"/>
+              </a:spcAft>
+              <a:defRPr b="1" sz="1100">
+                <a:solidFill>
+                  <a:srgbClr val="16A34A"/>
+                </a:solidFill>
+              </a:defRPr>
+            </a:pPr>
+            <a:r>
+              <a:t>+ Heuristic Auto-Allocation Engine: </a:t>
+            </a:r>
+            <a:r>
+              <a:rPr b="0">
+                <a:solidFill>
+                  <a:srgbClr val="334155"/>
+                </a:solidFill>
+              </a:rPr>
+              <a:t>Least-loaded mentor assignment under max-capacity limits.</a:t>
+            </a:r>
+          </a:p>
+          <a:p>
+            <a:pPr>
+              <a:spcAft>
+                <a:spcPts val="800"/>
+              </a:spcAft>
+              <a:defRPr b="1" sz="1100">
+                <a:solidFill>
+                  <a:srgbClr val="16A34A"/>
+                </a:solidFill>
+              </a:defRPr>
+            </a:pPr>
+            <a:r>
+              <a:t>+ Multi-factor Readiness Matrix: </a:t>
+            </a:r>
+            <a:r>
+              <a:rPr b="0">
+                <a:solidFill>
+                  <a:srgbClr val="334155"/>
+                </a:solidFill>
+              </a:rPr>
+              <a:t>25% per approved artifact, minus 25% penalties for missing mentor or bad team.</a:t>
+            </a:r>
+          </a:p>
+          <a:p>
+            <a:pPr>
+              <a:spcAft>
+                <a:spcPts val="800"/>
+              </a:spcAft>
+              <a:defRPr b="1" sz="1100">
+                <a:solidFill>
+                  <a:srgbClr val="16A34A"/>
+                </a:solidFill>
+              </a:defRPr>
+            </a:pPr>
+            <a:r>
+              <a:t>+ Resilient Fallback Mode: </a:t>
+            </a:r>
+            <a:r>
+              <a:rPr b="0">
+                <a:solidFill>
+                  <a:srgbClr val="334155"/>
+                </a:solidFill>
+              </a:rPr>
+              <a:t>Zero-config in-memory demo with hot-switch MongoDB persistence.</a:t>
             </a:r>
           </a:p>
         </p:txBody>
@@ -3247,62 +3754,798 @@
       <p:grpSpPr/>
       <p:sp>
         <p:nvSpPr>
-          <p:cNvPr id="2" name="Title 1"/>
-          <p:cNvSpPr>
-            <a:spLocks noGrp="1"/>
-          </p:cNvSpPr>
-          <p:nvPr>
-            <p:ph type="title"/>
-          </p:nvPr>
-        </p:nvSpPr>
-        <p:spPr/>
-        <p:txBody>
-          <a:bodyPr/>
-          <a:lstStyle/>
-          <a:p>
-            <a:r>
-              <a:t>Objectives</a:t>
-            </a:r>
-          </a:p>
-        </p:txBody>
-      </p:sp>
-      <p:sp>
-        <p:nvSpPr>
-          <p:cNvPr id="3" name="Content Placeholder 2"/>
-          <p:cNvSpPr>
-            <a:spLocks noGrp="1"/>
-          </p:cNvSpPr>
-          <p:nvPr>
-            <p:ph idx="1"/>
-          </p:nvPr>
-        </p:nvSpPr>
-        <p:spPr/>
-        <p:txBody>
-          <a:bodyPr/>
-          <a:lstStyle/>
-          <a:p>
-            <a:r>
-              <a:t>1. Block invalid teams (6 members, min 1 female)</a:t>
-            </a:r>
-          </a:p>
-          <a:p>
-            <a:r>
-              <a:t>2. Official SIH number search + duplicate check</a:t>
-            </a:r>
-          </a:p>
-          <a:p>
-            <a:r>
-              <a:t>3. Mentor load view + auto-assign</a:t>
-            </a:r>
-          </a:p>
-          <a:p>
-            <a:r>
-              <a:t>4. Deliverable tracker + readiness %</a:t>
-            </a:r>
-          </a:p>
-          <a:p>
-            <a:r>
-              <a:t>5. Dashboard + CSV/PDF export</a:t>
+          <p:cNvPr id="2" name="TextBox 1"/>
+          <p:cNvSpPr txBox="1"/>
+          <p:nvPr/>
+        </p:nvSpPr>
+        <p:spPr>
+          <a:xfrm>
+            <a:off x="731520" y="320040"/>
+            <a:ext cx="10698480" cy="320040"/>
+          </a:xfrm>
+          <a:prstGeom prst="rect">
+            <a:avLst/>
+          </a:prstGeom>
+          <a:noFill/>
+        </p:spPr>
+        <p:txBody>
+          <a:bodyPr wrap="none">
+            <a:spAutoFit/>
+          </a:bodyPr>
+          <a:lstStyle/>
+          <a:p>
+            <a:pPr>
+              <a:defRPr sz="1000" b="1">
+                <a:solidFill>
+                  <a:srgbClr val="2563EB"/>
+                </a:solidFill>
+              </a:defRPr>
+            </a:pPr>
+            <a:r>
+              <a:t>SIH COMMAND CENTER | PBL 14</a:t>
+            </a:r>
+          </a:p>
+        </p:txBody>
+      </p:sp>
+      <p:sp>
+        <p:nvSpPr>
+          <p:cNvPr id="3" name="TextBox 2"/>
+          <p:cNvSpPr txBox="1"/>
+          <p:nvPr/>
+        </p:nvSpPr>
+        <p:spPr>
+          <a:xfrm>
+            <a:off x="731520" y="621792"/>
+            <a:ext cx="10698480" cy="640080"/>
+          </a:xfrm>
+          <a:prstGeom prst="rect">
+            <a:avLst/>
+          </a:prstGeom>
+          <a:noFill/>
+        </p:spPr>
+        <p:txBody>
+          <a:bodyPr wrap="none">
+            <a:spAutoFit/>
+          </a:bodyPr>
+          <a:lstStyle/>
+          <a:p>
+            <a:pPr>
+              <a:defRPr sz="2200" b="1">
+                <a:solidFill>
+                  <a:srgbClr val="0F172A"/>
+                </a:solidFill>
+              </a:defRPr>
+            </a:pPr>
+            <a:r>
+              <a:t>High-Level Architecture &amp; Persistence Strategy</a:t>
+            </a:r>
+          </a:p>
+        </p:txBody>
+      </p:sp>
+      <p:sp>
+        <p:nvSpPr>
+          <p:cNvPr id="4" name="Rounded Rectangle 3"/>
+          <p:cNvSpPr/>
+          <p:nvPr/>
+        </p:nvSpPr>
+        <p:spPr>
+          <a:xfrm>
+            <a:off x="731520" y="1371600"/>
+            <a:ext cx="3383280" cy="3383280"/>
+          </a:xfrm>
+          <a:prstGeom prst="roundRect">
+            <a:avLst/>
+          </a:prstGeom>
+          <a:solidFill>
+            <a:srgbClr val="FFFFFF"/>
+          </a:solidFill>
+          <a:ln w="12700">
+            <a:solidFill>
+              <a:srgbClr val="E2E8F0"/>
+            </a:solidFill>
+          </a:ln>
+        </p:spPr>
+        <p:style>
+          <a:lnRef idx="1">
+            <a:schemeClr val="accent1"/>
+          </a:lnRef>
+          <a:fillRef idx="3">
+            <a:schemeClr val="accent1"/>
+          </a:fillRef>
+          <a:effectRef idx="2">
+            <a:schemeClr val="accent1"/>
+          </a:effectRef>
+          <a:fontRef idx="minor">
+            <a:schemeClr val="lt1"/>
+          </a:fontRef>
+        </p:style>
+        <p:txBody>
+          <a:bodyPr rtlCol="0" anchor="ctr"/>
+          <a:lstStyle/>
+          <a:p>
+            <a:pPr algn="ctr"/>
+          </a:p>
+        </p:txBody>
+      </p:sp>
+      <p:sp>
+        <p:nvSpPr>
+          <p:cNvPr id="5" name="TextBox 4"/>
+          <p:cNvSpPr txBox="1"/>
+          <p:nvPr/>
+        </p:nvSpPr>
+        <p:spPr>
+          <a:xfrm>
+            <a:off x="914400" y="1508760"/>
+            <a:ext cx="3017520" cy="411480"/>
+          </a:xfrm>
+          <a:prstGeom prst="rect">
+            <a:avLst/>
+          </a:prstGeom>
+          <a:noFill/>
+        </p:spPr>
+        <p:txBody>
+          <a:bodyPr wrap="none">
+            <a:spAutoFit/>
+          </a:bodyPr>
+          <a:lstStyle/>
+          <a:p>
+            <a:pPr>
+              <a:defRPr sz="1300" b="1">
+                <a:solidFill>
+                  <a:srgbClr val="0F172A"/>
+                </a:solidFill>
+              </a:defRPr>
+            </a:pPr>
+            <a:r>
+              <a:t>1. Client Tier (Zero-Build)</a:t>
+            </a:r>
+          </a:p>
+        </p:txBody>
+      </p:sp>
+      <p:sp>
+        <p:nvSpPr>
+          <p:cNvPr id="6" name="TextBox 5"/>
+          <p:cNvSpPr txBox="1"/>
+          <p:nvPr/>
+        </p:nvSpPr>
+        <p:spPr>
+          <a:xfrm>
+            <a:off x="868680" y="1965960"/>
+            <a:ext cx="3108960" cy="2651760"/>
+          </a:xfrm>
+          <a:prstGeom prst="rect">
+            <a:avLst/>
+          </a:prstGeom>
+          <a:noFill/>
+        </p:spPr>
+        <p:txBody>
+          <a:bodyPr wrap="square">
+            <a:spAutoFit/>
+          </a:bodyPr>
+          <a:lstStyle/>
+          <a:p>
+            <a:pPr>
+              <a:spcAft>
+                <a:spcPts val="800"/>
+              </a:spcAft>
+              <a:defRPr b="1" sz="1100">
+                <a:solidFill>
+                  <a:srgbClr val="0F172A"/>
+                </a:solidFill>
+              </a:defRPr>
+            </a:pPr>
+            <a:r>
+              <a:t>- Guided flow: </a:t>
+            </a:r>
+            <a:r>
+              <a:rPr b="0">
+                <a:solidFill>
+                  <a:srgbClr val="334155"/>
+                </a:solidFill>
+              </a:rPr>
+              <a:t>5 responsive HTML views, no build step.</a:t>
+            </a:r>
+          </a:p>
+          <a:p>
+            <a:pPr>
+              <a:spcAft>
+                <a:spcPts val="800"/>
+              </a:spcAft>
+              <a:defRPr b="1" sz="1100">
+                <a:solidFill>
+                  <a:srgbClr val="0F172A"/>
+                </a:solidFill>
+              </a:defRPr>
+            </a:pPr>
+            <a:r>
+              <a:t>- Fetch bridge: </a:t>
+            </a:r>
+            <a:r>
+              <a:rPr b="0">
+                <a:solidFill>
+                  <a:srgbClr val="334155"/>
+                </a:solidFill>
+              </a:rPr>
+              <a:t>unified async client in app.js.</a:t>
+            </a:r>
+          </a:p>
+          <a:p>
+            <a:pPr>
+              <a:spcAft>
+                <a:spcPts val="800"/>
+              </a:spcAft>
+              <a:defRPr b="1" sz="1100">
+                <a:solidFill>
+                  <a:srgbClr val="0F172A"/>
+                </a:solidFill>
+              </a:defRPr>
+            </a:pPr>
+            <a:r>
+              <a:t>- Sanitized output: </a:t>
+            </a:r>
+            <a:r>
+              <a:rPr b="0">
+                <a:solidFill>
+                  <a:srgbClr val="334155"/>
+                </a:solidFill>
+              </a:rPr>
+              <a:t>esc() filter on every render.</a:t>
+            </a:r>
+          </a:p>
+          <a:p>
+            <a:pPr>
+              <a:spcAft>
+                <a:spcPts val="800"/>
+              </a:spcAft>
+              <a:defRPr b="1" sz="1100">
+                <a:solidFill>
+                  <a:srgbClr val="0F172A"/>
+                </a:solidFill>
+              </a:defRPr>
+            </a:pPr>
+            <a:r>
+              <a:t>- Mobile adaptive: </a:t>
+            </a:r>
+            <a:r>
+              <a:rPr b="0">
+                <a:solidFill>
+                  <a:srgbClr val="334155"/>
+                </a:solidFill>
+              </a:rPr>
+              <a:t>media queries for 390-640px.</a:t>
+            </a:r>
+          </a:p>
+        </p:txBody>
+      </p:sp>
+      <p:sp>
+        <p:nvSpPr>
+          <p:cNvPr id="7" name="Rounded Rectangle 6"/>
+          <p:cNvSpPr/>
+          <p:nvPr/>
+        </p:nvSpPr>
+        <p:spPr>
+          <a:xfrm>
+            <a:off x="4389120" y="1371600"/>
+            <a:ext cx="3383280" cy="3383280"/>
+          </a:xfrm>
+          <a:prstGeom prst="roundRect">
+            <a:avLst/>
+          </a:prstGeom>
+          <a:solidFill>
+            <a:srgbClr val="FFFFFF"/>
+          </a:solidFill>
+          <a:ln w="12700">
+            <a:solidFill>
+              <a:srgbClr val="E2E8F0"/>
+            </a:solidFill>
+          </a:ln>
+        </p:spPr>
+        <p:style>
+          <a:lnRef idx="1">
+            <a:schemeClr val="accent1"/>
+          </a:lnRef>
+          <a:fillRef idx="3">
+            <a:schemeClr val="accent1"/>
+          </a:fillRef>
+          <a:effectRef idx="2">
+            <a:schemeClr val="accent1"/>
+          </a:effectRef>
+          <a:fontRef idx="minor">
+            <a:schemeClr val="lt1"/>
+          </a:fontRef>
+        </p:style>
+        <p:txBody>
+          <a:bodyPr rtlCol="0" anchor="ctr"/>
+          <a:lstStyle/>
+          <a:p>
+            <a:pPr algn="ctr"/>
+          </a:p>
+        </p:txBody>
+      </p:sp>
+      <p:sp>
+        <p:nvSpPr>
+          <p:cNvPr id="8" name="TextBox 7"/>
+          <p:cNvSpPr txBox="1"/>
+          <p:nvPr/>
+        </p:nvSpPr>
+        <p:spPr>
+          <a:xfrm>
+            <a:off x="4572000" y="1508760"/>
+            <a:ext cx="3017520" cy="411480"/>
+          </a:xfrm>
+          <a:prstGeom prst="rect">
+            <a:avLst/>
+          </a:prstGeom>
+          <a:noFill/>
+        </p:spPr>
+        <p:txBody>
+          <a:bodyPr wrap="none">
+            <a:spAutoFit/>
+          </a:bodyPr>
+          <a:lstStyle/>
+          <a:p>
+            <a:pPr>
+              <a:defRPr sz="1300" b="1">
+                <a:solidFill>
+                  <a:srgbClr val="0F172A"/>
+                </a:solidFill>
+              </a:defRPr>
+            </a:pPr>
+            <a:r>
+              <a:t>2. API Engine (Express)</a:t>
+            </a:r>
+          </a:p>
+        </p:txBody>
+      </p:sp>
+      <p:sp>
+        <p:nvSpPr>
+          <p:cNvPr id="9" name="TextBox 8"/>
+          <p:cNvSpPr txBox="1"/>
+          <p:nvPr/>
+        </p:nvSpPr>
+        <p:spPr>
+          <a:xfrm>
+            <a:off x="4526280" y="1965960"/>
+            <a:ext cx="3108960" cy="2651760"/>
+          </a:xfrm>
+          <a:prstGeom prst="rect">
+            <a:avLst/>
+          </a:prstGeom>
+          <a:noFill/>
+        </p:spPr>
+        <p:txBody>
+          <a:bodyPr wrap="square">
+            <a:spAutoFit/>
+          </a:bodyPr>
+          <a:lstStyle/>
+          <a:p>
+            <a:pPr>
+              <a:spcAft>
+                <a:spcPts val="800"/>
+              </a:spcAft>
+              <a:defRPr b="1" sz="1100">
+                <a:solidFill>
+                  <a:srgbClr val="0F172A"/>
+                </a:solidFill>
+              </a:defRPr>
+            </a:pPr>
+            <a:r>
+              <a:t>- 15 REST routes: </a:t>
+            </a:r>
+            <a:r>
+              <a:rPr b="0">
+                <a:solidFill>
+                  <a:srgbClr val="334155"/>
+                </a:solidFill>
+              </a:rPr>
+              <a:t>teams, PS, mentors, deliverables.</a:t>
+            </a:r>
+          </a:p>
+          <a:p>
+            <a:pPr>
+              <a:spcAft>
+                <a:spcPts val="800"/>
+              </a:spcAft>
+              <a:defRPr b="1" sz="1100">
+                <a:solidFill>
+                  <a:srgbClr val="0F172A"/>
+                </a:solidFill>
+              </a:defRPr>
+            </a:pPr>
+            <a:r>
+              <a:t>- Hardened parsing: </a:t>
+            </a:r>
+            <a:r>
+              <a:rPr b="0">
+                <a:solidFill>
+                  <a:srgbClr val="334155"/>
+                </a:solidFill>
+              </a:rPr>
+              <a:t>JSON shape + size enforcement.</a:t>
+            </a:r>
+          </a:p>
+          <a:p>
+            <a:pPr>
+              <a:spcAft>
+                <a:spcPts val="800"/>
+              </a:spcAft>
+              <a:defRPr b="1" sz="1100">
+                <a:solidFill>
+                  <a:srgbClr val="0F172A"/>
+                </a:solidFill>
+              </a:defRPr>
+            </a:pPr>
+            <a:r>
+              <a:t>- SIH scraper: </a:t>
+            </a:r>
+            <a:r>
+              <a:rPr b="0">
+                <a:solidFill>
+                  <a:srgbClr val="334155"/>
+                </a:solidFill>
+              </a:rPr>
+              <a:t>live ingest from sih.gov.in.</a:t>
+            </a:r>
+          </a:p>
+          <a:p>
+            <a:pPr>
+              <a:spcAft>
+                <a:spcPts val="800"/>
+              </a:spcAft>
+              <a:defRPr b="1" sz="1100">
+                <a:solidFill>
+                  <a:srgbClr val="0F172A"/>
+                </a:solidFill>
+              </a:defRPr>
+            </a:pPr>
+            <a:r>
+              <a:t>- Exports: </a:t>
+            </a:r>
+            <a:r>
+              <a:rPr b="0">
+                <a:solidFill>
+                  <a:srgbClr val="334155"/>
+                </a:solidFill>
+              </a:rPr>
+              <a:t>RFC 4180 CSV + printable report.</a:t>
+            </a:r>
+          </a:p>
+        </p:txBody>
+      </p:sp>
+      <p:sp>
+        <p:nvSpPr>
+          <p:cNvPr id="10" name="Rounded Rectangle 9"/>
+          <p:cNvSpPr/>
+          <p:nvPr/>
+        </p:nvSpPr>
+        <p:spPr>
+          <a:xfrm>
+            <a:off x="8046720" y="1371600"/>
+            <a:ext cx="3383280" cy="3383280"/>
+          </a:xfrm>
+          <a:prstGeom prst="roundRect">
+            <a:avLst/>
+          </a:prstGeom>
+          <a:solidFill>
+            <a:srgbClr val="FFFFFF"/>
+          </a:solidFill>
+          <a:ln w="12700">
+            <a:solidFill>
+              <a:srgbClr val="E2E8F0"/>
+            </a:solidFill>
+          </a:ln>
+        </p:spPr>
+        <p:style>
+          <a:lnRef idx="1">
+            <a:schemeClr val="accent1"/>
+          </a:lnRef>
+          <a:fillRef idx="3">
+            <a:schemeClr val="accent1"/>
+          </a:fillRef>
+          <a:effectRef idx="2">
+            <a:schemeClr val="accent1"/>
+          </a:effectRef>
+          <a:fontRef idx="minor">
+            <a:schemeClr val="lt1"/>
+          </a:fontRef>
+        </p:style>
+        <p:txBody>
+          <a:bodyPr rtlCol="0" anchor="ctr"/>
+          <a:lstStyle/>
+          <a:p>
+            <a:pPr algn="ctr"/>
+          </a:p>
+        </p:txBody>
+      </p:sp>
+      <p:sp>
+        <p:nvSpPr>
+          <p:cNvPr id="11" name="TextBox 10"/>
+          <p:cNvSpPr txBox="1"/>
+          <p:nvPr/>
+        </p:nvSpPr>
+        <p:spPr>
+          <a:xfrm>
+            <a:off x="8229600" y="1508760"/>
+            <a:ext cx="3017520" cy="411480"/>
+          </a:xfrm>
+          <a:prstGeom prst="rect">
+            <a:avLst/>
+          </a:prstGeom>
+          <a:noFill/>
+        </p:spPr>
+        <p:txBody>
+          <a:bodyPr wrap="none">
+            <a:spAutoFit/>
+          </a:bodyPr>
+          <a:lstStyle/>
+          <a:p>
+            <a:pPr>
+              <a:defRPr sz="1300" b="1">
+                <a:solidFill>
+                  <a:srgbClr val="0F172A"/>
+                </a:solidFill>
+              </a:defRPr>
+            </a:pPr>
+            <a:r>
+              <a:t>3. Dual-Tier Persistence</a:t>
+            </a:r>
+          </a:p>
+        </p:txBody>
+      </p:sp>
+      <p:sp>
+        <p:nvSpPr>
+          <p:cNvPr id="12" name="TextBox 11"/>
+          <p:cNvSpPr txBox="1"/>
+          <p:nvPr/>
+        </p:nvSpPr>
+        <p:spPr>
+          <a:xfrm>
+            <a:off x="8183879" y="1965960"/>
+            <a:ext cx="3108960" cy="2651760"/>
+          </a:xfrm>
+          <a:prstGeom prst="rect">
+            <a:avLst/>
+          </a:prstGeom>
+          <a:noFill/>
+        </p:spPr>
+        <p:txBody>
+          <a:bodyPr wrap="square">
+            <a:spAutoFit/>
+          </a:bodyPr>
+          <a:lstStyle/>
+          <a:p>
+            <a:pPr>
+              <a:spcAft>
+                <a:spcPts val="800"/>
+              </a:spcAft>
+              <a:defRPr b="1" sz="1100">
+                <a:solidFill>
+                  <a:srgbClr val="0F172A"/>
+                </a:solidFill>
+              </a:defRPr>
+            </a:pPr>
+            <a:r>
+              <a:t>- In-memory default: </a:t>
+            </a:r>
+            <a:r>
+              <a:rPr b="0">
+                <a:solidFill>
+                  <a:srgbClr val="334155"/>
+                </a:solidFill>
+              </a:rPr>
+              <a:t>instant demo, no Mongo needed.</a:t>
+            </a:r>
+          </a:p>
+          <a:p>
+            <a:pPr>
+              <a:spcAft>
+                <a:spcPts val="800"/>
+              </a:spcAft>
+              <a:defRPr b="1" sz="1100">
+                <a:solidFill>
+                  <a:srgbClr val="0F172A"/>
+                </a:solidFill>
+              </a:defRPr>
+            </a:pPr>
+            <a:r>
+              <a:t>- Mongo via Mongoose: </a:t>
+            </a:r>
+            <a:r>
+              <a:rPr b="0">
+                <a:solidFill>
+                  <a:srgbClr val="334155"/>
+                </a:solidFill>
+              </a:rPr>
+              <a:t>activates on MONGO_URI.</a:t>
+            </a:r>
+          </a:p>
+          <a:p>
+            <a:pPr>
+              <a:spcAft>
+                <a:spcPts val="800"/>
+              </a:spcAft>
+              <a:defRPr b="1" sz="1100">
+                <a:solidFill>
+                  <a:srgbClr val="0F172A"/>
+                </a:solidFill>
+              </a:defRPr>
+            </a:pPr>
+            <a:r>
+              <a:t>- Graceful fallback: </a:t>
+            </a:r>
+            <a:r>
+              <a:rPr b="0">
+                <a:solidFill>
+                  <a:srgbClr val="334155"/>
+                </a:solidFill>
+              </a:rPr>
+              <a:t>DB failure drops to memory.</a:t>
+            </a:r>
+          </a:p>
+          <a:p>
+            <a:pPr>
+              <a:spcAft>
+                <a:spcPts val="800"/>
+              </a:spcAft>
+              <a:defRPr b="1" sz="1100">
+                <a:solidFill>
+                  <a:srgbClr val="0F172A"/>
+                </a:solidFill>
+              </a:defRPr>
+            </a:pPr>
+            <a:r>
+              <a:t>- Crash-resistant: </a:t>
+            </a:r>
+            <a:r>
+              <a:rPr b="0">
+                <a:solidFill>
+                  <a:srgbClr val="334155"/>
+                </a:solidFill>
+              </a:rPr>
+              <a:t>bad payloads return 400/500.</a:t>
+            </a:r>
+          </a:p>
+        </p:txBody>
+      </p:sp>
+      <p:sp>
+        <p:nvSpPr>
+          <p:cNvPr id="13" name="Rounded Rectangle 12"/>
+          <p:cNvSpPr/>
+          <p:nvPr/>
+        </p:nvSpPr>
+        <p:spPr>
+          <a:xfrm>
+            <a:off x="731520" y="4892040"/>
+            <a:ext cx="10698480" cy="1463040"/>
+          </a:xfrm>
+          <a:prstGeom prst="roundRect">
+            <a:avLst/>
+          </a:prstGeom>
+          <a:solidFill>
+            <a:srgbClr val="FFFFFF"/>
+          </a:solidFill>
+          <a:ln w="12700">
+            <a:solidFill>
+              <a:srgbClr val="E2E8F0"/>
+            </a:solidFill>
+          </a:ln>
+        </p:spPr>
+        <p:style>
+          <a:lnRef idx="1">
+            <a:schemeClr val="accent1"/>
+          </a:lnRef>
+          <a:fillRef idx="3">
+            <a:schemeClr val="accent1"/>
+          </a:fillRef>
+          <a:effectRef idx="2">
+            <a:schemeClr val="accent1"/>
+          </a:effectRef>
+          <a:fontRef idx="minor">
+            <a:schemeClr val="lt1"/>
+          </a:fontRef>
+        </p:style>
+        <p:txBody>
+          <a:bodyPr rtlCol="0" anchor="ctr"/>
+          <a:lstStyle/>
+          <a:p>
+            <a:pPr algn="ctr"/>
+          </a:p>
+        </p:txBody>
+      </p:sp>
+      <p:sp>
+        <p:nvSpPr>
+          <p:cNvPr id="14" name="TextBox 13"/>
+          <p:cNvSpPr txBox="1"/>
+          <p:nvPr/>
+        </p:nvSpPr>
+        <p:spPr>
+          <a:xfrm>
+            <a:off x="914400" y="5029200"/>
+            <a:ext cx="10332720" cy="411480"/>
+          </a:xfrm>
+          <a:prstGeom prst="rect">
+            <a:avLst/>
+          </a:prstGeom>
+          <a:noFill/>
+        </p:spPr>
+        <p:txBody>
+          <a:bodyPr wrap="none">
+            <a:spAutoFit/>
+          </a:bodyPr>
+          <a:lstStyle/>
+          <a:p>
+            <a:pPr>
+              <a:defRPr sz="1300" b="1">
+                <a:solidFill>
+                  <a:srgbClr val="0F172A"/>
+                </a:solidFill>
+              </a:defRPr>
+            </a:pPr>
+            <a:r>
+              <a:t>Data Model &amp; Entity Relationships</a:t>
+            </a:r>
+          </a:p>
+        </p:txBody>
+      </p:sp>
+      <p:sp>
+        <p:nvSpPr>
+          <p:cNvPr id="15" name="TextBox 14"/>
+          <p:cNvSpPr txBox="1"/>
+          <p:nvPr/>
+        </p:nvSpPr>
+        <p:spPr>
+          <a:xfrm>
+            <a:off x="914400" y="5394960"/>
+            <a:ext cx="10332720" cy="914400"/>
+          </a:xfrm>
+          <a:prstGeom prst="rect">
+            <a:avLst/>
+          </a:prstGeom>
+          <a:noFill/>
+        </p:spPr>
+        <p:txBody>
+          <a:bodyPr wrap="square">
+            <a:spAutoFit/>
+          </a:bodyPr>
+          <a:lstStyle/>
+          <a:p>
+            <a:pPr>
+              <a:spcAft>
+                <a:spcPts val="800"/>
+              </a:spcAft>
+              <a:defRPr b="1" sz="1100">
+                <a:solidFill>
+                  <a:srgbClr val="0F172A"/>
+                </a:solidFill>
+              </a:defRPr>
+            </a:pPr>
+            <a:r>
+              <a:rPr b="0">
+                <a:solidFill>
+                  <a:srgbClr val="334155"/>
+                </a:solidFill>
+              </a:rPr>
+              <a:t>Teams {id, name, leadEmail, members[6], psId, mentorId} | PS {id, code, sihId, title, category, org, takenBy}</a:t>
+            </a:r>
+          </a:p>
+          <a:p>
+            <a:pPr>
+              <a:spcAft>
+                <a:spcPts val="800"/>
+              </a:spcAft>
+              <a:defRPr b="1" sz="1100">
+                <a:solidFill>
+                  <a:srgbClr val="0F172A"/>
+                </a:solidFill>
+              </a:defRPr>
+            </a:pPr>
+            <a:r>
+              <a:rPr b="0">
+                <a:solidFill>
+                  <a:srgbClr val="334155"/>
+                </a:solidFill>
+              </a:rPr>
+              <a:t>Mentors {id, name, dept, maxTeams, load} | Deliverables {teamId, type, link, status} 1:4 | Milestones {id, name, date, daysLeft}</a:t>
             </a:r>
           </a:p>
         </p:txBody>
@@ -3327,57 +4570,758 @@
       <p:grpSpPr/>
       <p:sp>
         <p:nvSpPr>
-          <p:cNvPr id="2" name="Title 1"/>
-          <p:cNvSpPr>
-            <a:spLocks noGrp="1"/>
-          </p:cNvSpPr>
-          <p:nvPr>
-            <p:ph type="title"/>
-          </p:nvPr>
-        </p:nvSpPr>
-        <p:spPr/>
-        <p:txBody>
-          <a:bodyPr/>
-          <a:lstStyle/>
-          <a:p>
-            <a:r>
-              <a:t>Design</a:t>
-            </a:r>
-          </a:p>
-        </p:txBody>
-      </p:sp>
-      <p:sp>
-        <p:nvSpPr>
-          <p:cNvPr id="3" name="Content Placeholder 2"/>
-          <p:cNvSpPr>
-            <a:spLocks noGrp="1"/>
-          </p:cNvSpPr>
-          <p:nvPr>
-            <p:ph idx="1"/>
-          </p:nvPr>
-        </p:nvSpPr>
-        <p:spPr/>
-        <p:txBody>
-          <a:bodyPr/>
-          <a:lstStyle/>
-          <a:p>
-            <a:r>
-              <a:t>Browser -&gt; Express REST (5000) -&gt; Mongo or memory</a:t>
-            </a:r>
-          </a:p>
-          <a:p>
-            <a:r>
-              <a:t>Tables: Team, PS (sihId), Mentor, Deliverable</a:t>
-            </a:r>
-          </a:p>
-          <a:p>
-            <a:r>
-              <a:t>Readiness = approved/4 - penalties</a:t>
-            </a:r>
-          </a:p>
-          <a:p>
-            <a:r>
-              <a:t>5 pages, one CSS file</a:t>
+          <p:cNvPr id="2" name="TextBox 1"/>
+          <p:cNvSpPr txBox="1"/>
+          <p:nvPr/>
+        </p:nvSpPr>
+        <p:spPr>
+          <a:xfrm>
+            <a:off x="731520" y="320040"/>
+            <a:ext cx="10698480" cy="320040"/>
+          </a:xfrm>
+          <a:prstGeom prst="rect">
+            <a:avLst/>
+          </a:prstGeom>
+          <a:noFill/>
+        </p:spPr>
+        <p:txBody>
+          <a:bodyPr wrap="none">
+            <a:spAutoFit/>
+          </a:bodyPr>
+          <a:lstStyle/>
+          <a:p>
+            <a:pPr>
+              <a:defRPr sz="1000" b="1">
+                <a:solidFill>
+                  <a:srgbClr val="2563EB"/>
+                </a:solidFill>
+              </a:defRPr>
+            </a:pPr>
+            <a:r>
+              <a:t>SIH COMMAND CENTER | PBL 14</a:t>
+            </a:r>
+          </a:p>
+        </p:txBody>
+      </p:sp>
+      <p:sp>
+        <p:nvSpPr>
+          <p:cNvPr id="3" name="TextBox 2"/>
+          <p:cNvSpPr txBox="1"/>
+          <p:nvPr/>
+        </p:nvSpPr>
+        <p:spPr>
+          <a:xfrm>
+            <a:off x="731520" y="621792"/>
+            <a:ext cx="10698480" cy="640080"/>
+          </a:xfrm>
+          <a:prstGeom prst="rect">
+            <a:avLst/>
+          </a:prstGeom>
+          <a:noFill/>
+        </p:spPr>
+        <p:txBody>
+          <a:bodyPr wrap="none">
+            <a:spAutoFit/>
+          </a:bodyPr>
+          <a:lstStyle/>
+          <a:p>
+            <a:pPr>
+              <a:defRPr sz="2200" b="1">
+                <a:solidFill>
+                  <a:srgbClr val="0F172A"/>
+                </a:solidFill>
+              </a:defRPr>
+            </a:pPr>
+            <a:r>
+              <a:t>Engineering Deliverables: What Has Been Built</a:t>
+            </a:r>
+          </a:p>
+        </p:txBody>
+      </p:sp>
+      <p:sp>
+        <p:nvSpPr>
+          <p:cNvPr id="4" name="Rounded Rectangle 3"/>
+          <p:cNvSpPr/>
+          <p:nvPr/>
+        </p:nvSpPr>
+        <p:spPr>
+          <a:xfrm>
+            <a:off x="731520" y="1371600"/>
+            <a:ext cx="5120640" cy="2377440"/>
+          </a:xfrm>
+          <a:prstGeom prst="roundRect">
+            <a:avLst/>
+          </a:prstGeom>
+          <a:solidFill>
+            <a:srgbClr val="FFFFFF"/>
+          </a:solidFill>
+          <a:ln w="12700">
+            <a:solidFill>
+              <a:srgbClr val="E2E8F0"/>
+            </a:solidFill>
+          </a:ln>
+        </p:spPr>
+        <p:style>
+          <a:lnRef idx="1">
+            <a:schemeClr val="accent1"/>
+          </a:lnRef>
+          <a:fillRef idx="3">
+            <a:schemeClr val="accent1"/>
+          </a:fillRef>
+          <a:effectRef idx="2">
+            <a:schemeClr val="accent1"/>
+          </a:effectRef>
+          <a:fontRef idx="minor">
+            <a:schemeClr val="lt1"/>
+          </a:fontRef>
+        </p:style>
+        <p:txBody>
+          <a:bodyPr rtlCol="0" anchor="ctr"/>
+          <a:lstStyle/>
+          <a:p>
+            <a:pPr algn="ctr"/>
+          </a:p>
+        </p:txBody>
+      </p:sp>
+      <p:sp>
+        <p:nvSpPr>
+          <p:cNvPr id="5" name="TextBox 4"/>
+          <p:cNvSpPr txBox="1"/>
+          <p:nvPr/>
+        </p:nvSpPr>
+        <p:spPr>
+          <a:xfrm>
+            <a:off x="914400" y="1508760"/>
+            <a:ext cx="4754880" cy="411480"/>
+          </a:xfrm>
+          <a:prstGeom prst="rect">
+            <a:avLst/>
+          </a:prstGeom>
+          <a:noFill/>
+        </p:spPr>
+        <p:txBody>
+          <a:bodyPr wrap="none">
+            <a:spAutoFit/>
+          </a:bodyPr>
+          <a:lstStyle/>
+          <a:p>
+            <a:pPr>
+              <a:defRPr sz="1300" b="1">
+                <a:solidFill>
+                  <a:srgbClr val="0F172A"/>
+                </a:solidFill>
+              </a:defRPr>
+            </a:pPr>
+            <a:r>
+              <a:t>1. Team Roster Enforcement</a:t>
+            </a:r>
+          </a:p>
+        </p:txBody>
+      </p:sp>
+      <p:sp>
+        <p:nvSpPr>
+          <p:cNvPr id="6" name="TextBox 5"/>
+          <p:cNvSpPr txBox="1"/>
+          <p:nvPr/>
+        </p:nvSpPr>
+        <p:spPr>
+          <a:xfrm>
+            <a:off x="914400" y="1874519"/>
+            <a:ext cx="4754880" cy="1828800"/>
+          </a:xfrm>
+          <a:prstGeom prst="rect">
+            <a:avLst/>
+          </a:prstGeom>
+          <a:noFill/>
+        </p:spPr>
+        <p:txBody>
+          <a:bodyPr wrap="square">
+            <a:spAutoFit/>
+          </a:bodyPr>
+          <a:lstStyle/>
+          <a:p>
+            <a:pPr>
+              <a:spcAft>
+                <a:spcPts val="800"/>
+              </a:spcAft>
+              <a:defRPr b="1" sz="1100">
+                <a:solidFill>
+                  <a:srgbClr val="0F172A"/>
+                </a:solidFill>
+              </a:defRPr>
+            </a:pPr>
+            <a:r>
+              <a:t>- </a:t>
+            </a:r>
+            <a:r>
+              <a:rPr b="0">
+                <a:solidFill>
+                  <a:srgbClr val="334155"/>
+                </a:solidFill>
+              </a:rPr>
+              <a:t>Guided 3-step wizard with prefilled lead details.</a:t>
+            </a:r>
+          </a:p>
+          <a:p>
+            <a:pPr>
+              <a:spcAft>
+                <a:spcPts val="800"/>
+              </a:spcAft>
+              <a:defRPr b="1" sz="1100">
+                <a:solidFill>
+                  <a:srgbClr val="0F172A"/>
+                </a:solidFill>
+              </a:defRPr>
+            </a:pPr>
+            <a:r>
+              <a:t>- </a:t>
+            </a:r>
+            <a:r>
+              <a:rPr b="0">
+                <a:solidFill>
+                  <a:srgbClr val="334155"/>
+                </a:solidFill>
+              </a:rPr>
+              <a:t>Server validation: exactly 6, min 1 female.</a:t>
+            </a:r>
+          </a:p>
+          <a:p>
+            <a:pPr>
+              <a:spcAft>
+                <a:spcPts val="800"/>
+              </a:spcAft>
+              <a:defRPr b="1" sz="1100">
+                <a:solidFill>
+                  <a:srgbClr val="0F172A"/>
+                </a:solidFill>
+              </a:defRPr>
+            </a:pPr>
+            <a:r>
+              <a:t>- </a:t>
+            </a:r>
+            <a:r>
+              <a:rPr b="0">
+                <a:solidFill>
+                  <a:srgbClr val="334155"/>
+                </a:solidFill>
+              </a:rPr>
+              <a:t>Auto-provisions 4 deliverable slots per team.</a:t>
+            </a:r>
+          </a:p>
+        </p:txBody>
+      </p:sp>
+      <p:sp>
+        <p:nvSpPr>
+          <p:cNvPr id="7" name="Rounded Rectangle 6"/>
+          <p:cNvSpPr/>
+          <p:nvPr/>
+        </p:nvSpPr>
+        <p:spPr>
+          <a:xfrm>
+            <a:off x="6309360" y="1371600"/>
+            <a:ext cx="5120640" cy="2377440"/>
+          </a:xfrm>
+          <a:prstGeom prst="roundRect">
+            <a:avLst/>
+          </a:prstGeom>
+          <a:solidFill>
+            <a:srgbClr val="FFFFFF"/>
+          </a:solidFill>
+          <a:ln w="12700">
+            <a:solidFill>
+              <a:srgbClr val="E2E8F0"/>
+            </a:solidFill>
+          </a:ln>
+        </p:spPr>
+        <p:style>
+          <a:lnRef idx="1">
+            <a:schemeClr val="accent1"/>
+          </a:lnRef>
+          <a:fillRef idx="3">
+            <a:schemeClr val="accent1"/>
+          </a:fillRef>
+          <a:effectRef idx="2">
+            <a:schemeClr val="accent1"/>
+          </a:effectRef>
+          <a:fontRef idx="minor">
+            <a:schemeClr val="lt1"/>
+          </a:fontRef>
+        </p:style>
+        <p:txBody>
+          <a:bodyPr rtlCol="0" anchor="ctr"/>
+          <a:lstStyle/>
+          <a:p>
+            <a:pPr algn="ctr"/>
+          </a:p>
+        </p:txBody>
+      </p:sp>
+      <p:sp>
+        <p:nvSpPr>
+          <p:cNvPr id="8" name="TextBox 7"/>
+          <p:cNvSpPr txBox="1"/>
+          <p:nvPr/>
+        </p:nvSpPr>
+        <p:spPr>
+          <a:xfrm>
+            <a:off x="6492240" y="1508760"/>
+            <a:ext cx="4754880" cy="411480"/>
+          </a:xfrm>
+          <a:prstGeom prst="rect">
+            <a:avLst/>
+          </a:prstGeom>
+          <a:noFill/>
+        </p:spPr>
+        <p:txBody>
+          <a:bodyPr wrap="none">
+            <a:spAutoFit/>
+          </a:bodyPr>
+          <a:lstStyle/>
+          <a:p>
+            <a:pPr>
+              <a:defRPr sz="1300" b="1">
+                <a:solidFill>
+                  <a:srgbClr val="0F172A"/>
+                </a:solidFill>
+              </a:defRPr>
+            </a:pPr>
+            <a:r>
+              <a:t>2. PS Catalog &amp; Live Ingestion</a:t>
+            </a:r>
+          </a:p>
+        </p:txBody>
+      </p:sp>
+      <p:sp>
+        <p:nvSpPr>
+          <p:cNvPr id="9" name="TextBox 8"/>
+          <p:cNvSpPr txBox="1"/>
+          <p:nvPr/>
+        </p:nvSpPr>
+        <p:spPr>
+          <a:xfrm>
+            <a:off x="6492240" y="1874519"/>
+            <a:ext cx="4754880" cy="1828800"/>
+          </a:xfrm>
+          <a:prstGeom prst="rect">
+            <a:avLst/>
+          </a:prstGeom>
+          <a:noFill/>
+        </p:spPr>
+        <p:txBody>
+          <a:bodyPr wrap="square">
+            <a:spAutoFit/>
+          </a:bodyPr>
+          <a:lstStyle/>
+          <a:p>
+            <a:pPr>
+              <a:spcAft>
+                <a:spcPts val="800"/>
+              </a:spcAft>
+              <a:defRPr b="1" sz="1100">
+                <a:solidFill>
+                  <a:srgbClr val="0F172A"/>
+                </a:solidFill>
+              </a:defRPr>
+            </a:pPr>
+            <a:r>
+              <a:t>- </a:t>
+            </a:r>
+            <a:r>
+              <a:rPr b="0">
+                <a:solidFill>
+                  <a:srgbClr val="334155"/>
+                </a:solidFill>
+              </a:rPr>
+              <a:t>One-click scraper of official sih.gov.in table.</a:t>
+            </a:r>
+          </a:p>
+          <a:p>
+            <a:pPr>
+              <a:spcAft>
+                <a:spcPts val="800"/>
+              </a:spcAft>
+              <a:defRPr b="1" sz="1100">
+                <a:solidFill>
+                  <a:srgbClr val="0F172A"/>
+                </a:solidFill>
+              </a:defRPr>
+            </a:pPr>
+            <a:r>
+              <a:t>- </a:t>
+            </a:r>
+            <a:r>
+              <a:rPr b="0">
+                <a:solidFill>
+                  <a:srgbClr val="334155"/>
+                </a:solidFill>
+              </a:rPr>
+              <a:t>Search by SIH number (e.g. SIH25001).</a:t>
+            </a:r>
+          </a:p>
+          <a:p>
+            <a:pPr>
+              <a:spcAft>
+                <a:spcPts val="800"/>
+              </a:spcAft>
+              <a:defRPr b="1" sz="1100">
+                <a:solidFill>
+                  <a:srgbClr val="0F172A"/>
+                </a:solidFill>
+              </a:defRPr>
+            </a:pPr>
+            <a:r>
+              <a:t>- </a:t>
+            </a:r>
+            <a:r>
+              <a:rPr b="0">
+                <a:solidFill>
+                  <a:srgbClr val="334155"/>
+                </a:solidFill>
+              </a:rPr>
+              <a:t>Duplicate detection with allowDuplicate override.</a:t>
+            </a:r>
+          </a:p>
+        </p:txBody>
+      </p:sp>
+      <p:sp>
+        <p:nvSpPr>
+          <p:cNvPr id="10" name="Rounded Rectangle 9"/>
+          <p:cNvSpPr/>
+          <p:nvPr/>
+        </p:nvSpPr>
+        <p:spPr>
+          <a:xfrm>
+            <a:off x="731520" y="3931920"/>
+            <a:ext cx="5120640" cy="2377440"/>
+          </a:xfrm>
+          <a:prstGeom prst="roundRect">
+            <a:avLst/>
+          </a:prstGeom>
+          <a:solidFill>
+            <a:srgbClr val="FFFFFF"/>
+          </a:solidFill>
+          <a:ln w="12700">
+            <a:solidFill>
+              <a:srgbClr val="E2E8F0"/>
+            </a:solidFill>
+          </a:ln>
+        </p:spPr>
+        <p:style>
+          <a:lnRef idx="1">
+            <a:schemeClr val="accent1"/>
+          </a:lnRef>
+          <a:fillRef idx="3">
+            <a:schemeClr val="accent1"/>
+          </a:fillRef>
+          <a:effectRef idx="2">
+            <a:schemeClr val="accent1"/>
+          </a:effectRef>
+          <a:fontRef idx="minor">
+            <a:schemeClr val="lt1"/>
+          </a:fontRef>
+        </p:style>
+        <p:txBody>
+          <a:bodyPr rtlCol="0" anchor="ctr"/>
+          <a:lstStyle/>
+          <a:p>
+            <a:pPr algn="ctr"/>
+          </a:p>
+        </p:txBody>
+      </p:sp>
+      <p:sp>
+        <p:nvSpPr>
+          <p:cNvPr id="11" name="TextBox 10"/>
+          <p:cNvSpPr txBox="1"/>
+          <p:nvPr/>
+        </p:nvSpPr>
+        <p:spPr>
+          <a:xfrm>
+            <a:off x="914400" y="4069080"/>
+            <a:ext cx="4754880" cy="411480"/>
+          </a:xfrm>
+          <a:prstGeom prst="rect">
+            <a:avLst/>
+          </a:prstGeom>
+          <a:noFill/>
+        </p:spPr>
+        <p:txBody>
+          <a:bodyPr wrap="none">
+            <a:spAutoFit/>
+          </a:bodyPr>
+          <a:lstStyle/>
+          <a:p>
+            <a:pPr>
+              <a:defRPr sz="1300" b="1">
+                <a:solidFill>
+                  <a:srgbClr val="0F172A"/>
+                </a:solidFill>
+              </a:defRPr>
+            </a:pPr>
+            <a:r>
+              <a:t>3. Mentor Assignment Engine</a:t>
+            </a:r>
+          </a:p>
+        </p:txBody>
+      </p:sp>
+      <p:sp>
+        <p:nvSpPr>
+          <p:cNvPr id="12" name="TextBox 11"/>
+          <p:cNvSpPr txBox="1"/>
+          <p:nvPr/>
+        </p:nvSpPr>
+        <p:spPr>
+          <a:xfrm>
+            <a:off x="914400" y="4434840"/>
+            <a:ext cx="4754880" cy="1828800"/>
+          </a:xfrm>
+          <a:prstGeom prst="rect">
+            <a:avLst/>
+          </a:prstGeom>
+          <a:noFill/>
+        </p:spPr>
+        <p:txBody>
+          <a:bodyPr wrap="square">
+            <a:spAutoFit/>
+          </a:bodyPr>
+          <a:lstStyle/>
+          <a:p>
+            <a:pPr>
+              <a:spcAft>
+                <a:spcPts val="800"/>
+              </a:spcAft>
+              <a:defRPr b="1" sz="1100">
+                <a:solidFill>
+                  <a:srgbClr val="0F172A"/>
+                </a:solidFill>
+              </a:defRPr>
+            </a:pPr>
+            <a:r>
+              <a:t>- </a:t>
+            </a:r>
+            <a:r>
+              <a:rPr b="0">
+                <a:solidFill>
+                  <a:srgbClr val="334155"/>
+                </a:solidFill>
+              </a:rPr>
+              <a:t>Live load view: current teams vs maxTeams.</a:t>
+            </a:r>
+          </a:p>
+          <a:p>
+            <a:pPr>
+              <a:spcAft>
+                <a:spcPts val="800"/>
+              </a:spcAft>
+              <a:defRPr b="1" sz="1100">
+                <a:solidFill>
+                  <a:srgbClr val="0F172A"/>
+                </a:solidFill>
+              </a:defRPr>
+            </a:pPr>
+            <a:r>
+              <a:t>- </a:t>
+            </a:r>
+            <a:r>
+              <a:rPr b="0">
+                <a:solidFill>
+                  <a:srgbClr val="334155"/>
+                </a:solidFill>
+              </a:rPr>
+              <a:t>One-click auto-assign to least-loaded mentor.</a:t>
+            </a:r>
+          </a:p>
+          <a:p>
+            <a:pPr>
+              <a:spcAft>
+                <a:spcPts val="800"/>
+              </a:spcAft>
+              <a:defRPr b="1" sz="1100">
+                <a:solidFill>
+                  <a:srgbClr val="0F172A"/>
+                </a:solidFill>
+              </a:defRPr>
+            </a:pPr>
+            <a:r>
+              <a:t>- </a:t>
+            </a:r>
+            <a:r>
+              <a:rPr b="0">
+                <a:solidFill>
+                  <a:srgbClr val="334155"/>
+                </a:solidFill>
+              </a:rPr>
+              <a:t>Full mentors blocked automatically (400).</a:t>
+            </a:r>
+          </a:p>
+        </p:txBody>
+      </p:sp>
+      <p:sp>
+        <p:nvSpPr>
+          <p:cNvPr id="13" name="Rounded Rectangle 12"/>
+          <p:cNvSpPr/>
+          <p:nvPr/>
+        </p:nvSpPr>
+        <p:spPr>
+          <a:xfrm>
+            <a:off x="6309360" y="3931920"/>
+            <a:ext cx="5120640" cy="2377440"/>
+          </a:xfrm>
+          <a:prstGeom prst="roundRect">
+            <a:avLst/>
+          </a:prstGeom>
+          <a:solidFill>
+            <a:srgbClr val="FFFFFF"/>
+          </a:solidFill>
+          <a:ln w="12700">
+            <a:solidFill>
+              <a:srgbClr val="E2E8F0"/>
+            </a:solidFill>
+          </a:ln>
+        </p:spPr>
+        <p:style>
+          <a:lnRef idx="1">
+            <a:schemeClr val="accent1"/>
+          </a:lnRef>
+          <a:fillRef idx="3">
+            <a:schemeClr val="accent1"/>
+          </a:fillRef>
+          <a:effectRef idx="2">
+            <a:schemeClr val="accent1"/>
+          </a:effectRef>
+          <a:fontRef idx="minor">
+            <a:schemeClr val="lt1"/>
+          </a:fontRef>
+        </p:style>
+        <p:txBody>
+          <a:bodyPr rtlCol="0" anchor="ctr"/>
+          <a:lstStyle/>
+          <a:p>
+            <a:pPr algn="ctr"/>
+          </a:p>
+        </p:txBody>
+      </p:sp>
+      <p:sp>
+        <p:nvSpPr>
+          <p:cNvPr id="14" name="TextBox 13"/>
+          <p:cNvSpPr txBox="1"/>
+          <p:nvPr/>
+        </p:nvSpPr>
+        <p:spPr>
+          <a:xfrm>
+            <a:off x="6492240" y="4069080"/>
+            <a:ext cx="4754880" cy="411480"/>
+          </a:xfrm>
+          <a:prstGeom prst="rect">
+            <a:avLst/>
+          </a:prstGeom>
+          <a:noFill/>
+        </p:spPr>
+        <p:txBody>
+          <a:bodyPr wrap="none">
+            <a:spAutoFit/>
+          </a:bodyPr>
+          <a:lstStyle/>
+          <a:p>
+            <a:pPr>
+              <a:defRPr sz="1300" b="1">
+                <a:solidFill>
+                  <a:srgbClr val="0F172A"/>
+                </a:solidFill>
+              </a:defRPr>
+            </a:pPr>
+            <a:r>
+              <a:t>4. Readiness Dashboard</a:t>
+            </a:r>
+          </a:p>
+        </p:txBody>
+      </p:sp>
+      <p:sp>
+        <p:nvSpPr>
+          <p:cNvPr id="15" name="TextBox 14"/>
+          <p:cNvSpPr txBox="1"/>
+          <p:nvPr/>
+        </p:nvSpPr>
+        <p:spPr>
+          <a:xfrm>
+            <a:off x="6492240" y="4434840"/>
+            <a:ext cx="4754880" cy="1828800"/>
+          </a:xfrm>
+          <a:prstGeom prst="rect">
+            <a:avLst/>
+          </a:prstGeom>
+          <a:noFill/>
+        </p:spPr>
+        <p:txBody>
+          <a:bodyPr wrap="square">
+            <a:spAutoFit/>
+          </a:bodyPr>
+          <a:lstStyle/>
+          <a:p>
+            <a:pPr>
+              <a:spcAft>
+                <a:spcPts val="800"/>
+              </a:spcAft>
+              <a:defRPr b="1" sz="1100">
+                <a:solidFill>
+                  <a:srgbClr val="0F172A"/>
+                </a:solidFill>
+              </a:defRPr>
+            </a:pPr>
+            <a:r>
+              <a:t>- </a:t>
+            </a:r>
+            <a:r>
+              <a:rPr b="0">
+                <a:solidFill>
+                  <a:srgbClr val="334155"/>
+                </a:solidFill>
+              </a:rPr>
+              <a:t>4 items: GitHub, PPT, video, report.</a:t>
+            </a:r>
+          </a:p>
+          <a:p>
+            <a:pPr>
+              <a:spcAft>
+                <a:spcPts val="800"/>
+              </a:spcAft>
+              <a:defRPr b="1" sz="1100">
+                <a:solidFill>
+                  <a:srgbClr val="0F172A"/>
+                </a:solidFill>
+              </a:defRPr>
+            </a:pPr>
+            <a:r>
+              <a:t>- </a:t>
+            </a:r>
+            <a:r>
+              <a:rPr b="0">
+                <a:solidFill>
+                  <a:srgbClr val="334155"/>
+                </a:solidFill>
+              </a:rPr>
+              <a:t>Readiness = approved/4 minus 25% penalties.</a:t>
+            </a:r>
+          </a:p>
+          <a:p>
+            <a:pPr>
+              <a:spcAft>
+                <a:spcPts val="800"/>
+              </a:spcAft>
+              <a:defRPr b="1" sz="1100">
+                <a:solidFill>
+                  <a:srgbClr val="0F172A"/>
+                </a:solidFill>
+              </a:defRPr>
+            </a:pPr>
+            <a:r>
+              <a:t>- </a:t>
+            </a:r>
+            <a:r>
+              <a:rPr b="0">
+                <a:solidFill>
+                  <a:srgbClr val="334155"/>
+                </a:solidFill>
+              </a:rPr>
+              <a:t>CSV export + printable PDF-ready report.</a:t>
             </a:r>
           </a:p>
         </p:txBody>
@@ -3402,42 +5346,460 @@
       <p:grpSpPr/>
       <p:sp>
         <p:nvSpPr>
-          <p:cNvPr id="2" name="Title 1"/>
-          <p:cNvSpPr>
-            <a:spLocks noGrp="1"/>
-          </p:cNvSpPr>
-          <p:nvPr>
-            <p:ph type="title"/>
-          </p:nvPr>
-        </p:nvSpPr>
-        <p:spPr/>
-        <p:txBody>
-          <a:bodyPr/>
-          <a:lstStyle/>
-          <a:p>
-            <a:r>
-              <a:t>Demo flow</a:t>
-            </a:r>
-          </a:p>
-        </p:txBody>
-      </p:sp>
-      <p:sp>
-        <p:nvSpPr>
-          <p:cNvPr id="3" name="Content Placeholder 2"/>
-          <p:cNvSpPr>
-            <a:spLocks noGrp="1"/>
-          </p:cNvSpPr>
-          <p:nvPr>
-            <p:ph idx="1"/>
-          </p:nvPr>
-        </p:nvSpPr>
-        <p:spPr/>
-        <p:txBody>
-          <a:bodyPr/>
-          <a:lstStyle/>
-          <a:p>
-            <a:r>
-              <a:t>Live: register team (wizard) -&gt; search SIH25001 -&gt; auto-assign mentor -&gt; approve deliverable -&gt; readiness rises -&gt; export report</a:t>
+          <p:cNvPr id="2" name="TextBox 1"/>
+          <p:cNvSpPr txBox="1"/>
+          <p:nvPr/>
+        </p:nvSpPr>
+        <p:spPr>
+          <a:xfrm>
+            <a:off x="731520" y="320040"/>
+            <a:ext cx="10698480" cy="320040"/>
+          </a:xfrm>
+          <a:prstGeom prst="rect">
+            <a:avLst/>
+          </a:prstGeom>
+          <a:noFill/>
+        </p:spPr>
+        <p:txBody>
+          <a:bodyPr wrap="none">
+            <a:spAutoFit/>
+          </a:bodyPr>
+          <a:lstStyle/>
+          <a:p>
+            <a:pPr>
+              <a:defRPr sz="1000" b="1">
+                <a:solidFill>
+                  <a:srgbClr val="2563EB"/>
+                </a:solidFill>
+              </a:defRPr>
+            </a:pPr>
+            <a:r>
+              <a:t>SIH COMMAND CENTER | PBL 14</a:t>
+            </a:r>
+          </a:p>
+        </p:txBody>
+      </p:sp>
+      <p:sp>
+        <p:nvSpPr>
+          <p:cNvPr id="3" name="TextBox 2"/>
+          <p:cNvSpPr txBox="1"/>
+          <p:nvPr/>
+        </p:nvSpPr>
+        <p:spPr>
+          <a:xfrm>
+            <a:off x="731520" y="621792"/>
+            <a:ext cx="10698480" cy="640080"/>
+          </a:xfrm>
+          <a:prstGeom prst="rect">
+            <a:avLst/>
+          </a:prstGeom>
+          <a:noFill/>
+        </p:spPr>
+        <p:txBody>
+          <a:bodyPr wrap="none">
+            <a:spAutoFit/>
+          </a:bodyPr>
+          <a:lstStyle/>
+          <a:p>
+            <a:pPr>
+              <a:defRPr sz="2200" b="1">
+                <a:solidFill>
+                  <a:srgbClr val="0F172A"/>
+                </a:solidFill>
+              </a:defRPr>
+            </a:pPr>
+            <a:r>
+              <a:t>Security Hardening, Error Handling &amp; Concurrency Testing</a:t>
+            </a:r>
+          </a:p>
+        </p:txBody>
+      </p:sp>
+      <p:sp>
+        <p:nvSpPr>
+          <p:cNvPr id="4" name="Rounded Rectangle 3"/>
+          <p:cNvSpPr/>
+          <p:nvPr/>
+        </p:nvSpPr>
+        <p:spPr>
+          <a:xfrm>
+            <a:off x="731520" y="1371600"/>
+            <a:ext cx="5120640" cy="4937760"/>
+          </a:xfrm>
+          <a:prstGeom prst="roundRect">
+            <a:avLst/>
+          </a:prstGeom>
+          <a:solidFill>
+            <a:srgbClr val="FFFFFF"/>
+          </a:solidFill>
+          <a:ln w="12700">
+            <a:solidFill>
+              <a:srgbClr val="E2E8F0"/>
+            </a:solidFill>
+          </a:ln>
+        </p:spPr>
+        <p:style>
+          <a:lnRef idx="1">
+            <a:schemeClr val="accent1"/>
+          </a:lnRef>
+          <a:fillRef idx="3">
+            <a:schemeClr val="accent1"/>
+          </a:fillRef>
+          <a:effectRef idx="2">
+            <a:schemeClr val="accent1"/>
+          </a:effectRef>
+          <a:fontRef idx="minor">
+            <a:schemeClr val="lt1"/>
+          </a:fontRef>
+        </p:style>
+        <p:txBody>
+          <a:bodyPr rtlCol="0" anchor="ctr"/>
+          <a:lstStyle/>
+          <a:p>
+            <a:pPr algn="ctr"/>
+          </a:p>
+        </p:txBody>
+      </p:sp>
+      <p:sp>
+        <p:nvSpPr>
+          <p:cNvPr id="5" name="TextBox 4"/>
+          <p:cNvSpPr txBox="1"/>
+          <p:nvPr/>
+        </p:nvSpPr>
+        <p:spPr>
+          <a:xfrm>
+            <a:off x="914400" y="1508760"/>
+            <a:ext cx="4754880" cy="411480"/>
+          </a:xfrm>
+          <a:prstGeom prst="rect">
+            <a:avLst/>
+          </a:prstGeom>
+          <a:noFill/>
+        </p:spPr>
+        <p:txBody>
+          <a:bodyPr wrap="none">
+            <a:spAutoFit/>
+          </a:bodyPr>
+          <a:lstStyle/>
+          <a:p>
+            <a:pPr>
+              <a:defRPr sz="1300" b="1">
+                <a:solidFill>
+                  <a:srgbClr val="0F172A"/>
+                </a:solidFill>
+              </a:defRPr>
+            </a:pPr>
+            <a:r>
+              <a:t>Vulnerabilities Found &amp; Fixed</a:t>
+            </a:r>
+          </a:p>
+        </p:txBody>
+      </p:sp>
+      <p:sp>
+        <p:nvSpPr>
+          <p:cNvPr id="6" name="TextBox 5"/>
+          <p:cNvSpPr txBox="1"/>
+          <p:nvPr/>
+        </p:nvSpPr>
+        <p:spPr>
+          <a:xfrm>
+            <a:off x="914400" y="1965960"/>
+            <a:ext cx="4754880" cy="4206240"/>
+          </a:xfrm>
+          <a:prstGeom prst="rect">
+            <a:avLst/>
+          </a:prstGeom>
+          <a:noFill/>
+        </p:spPr>
+        <p:txBody>
+          <a:bodyPr wrap="square">
+            <a:spAutoFit/>
+          </a:bodyPr>
+          <a:lstStyle/>
+          <a:p>
+            <a:pPr>
+              <a:spcAft>
+                <a:spcPts val="800"/>
+              </a:spcAft>
+              <a:defRPr b="1" sz="1100">
+                <a:solidFill>
+                  <a:srgbClr val="0F172A"/>
+                </a:solidFill>
+              </a:defRPr>
+            </a:pPr>
+            <a:r>
+              <a:t>- DoS crash: </a:t>
+            </a:r>
+            <a:r>
+              <a:rPr b="0">
+                <a:solidFill>
+                  <a:srgbClr val="334155"/>
+                </a:solidFill>
+              </a:rPr>
+              <a:t>non-array members killed Node. Fixed with type guard + global error handler.</a:t>
+            </a:r>
+          </a:p>
+          <a:p>
+            <a:pPr>
+              <a:spcAft>
+                <a:spcPts val="800"/>
+              </a:spcAft>
+              <a:defRPr b="1" sz="1100">
+                <a:solidFill>
+                  <a:srgbClr val="0F172A"/>
+                </a:solidFill>
+              </a:defRPr>
+            </a:pPr>
+            <a:r>
+              <a:t>- Stored XSS: </a:t>
+            </a:r>
+            <a:r>
+              <a:rPr b="0">
+                <a:solidFill>
+                  <a:srgbClr val="334155"/>
+                </a:solidFill>
+              </a:rPr>
+              <a:t>team names ran in innerHTML. Fixed with esc() on backend report + all pages.</a:t>
+            </a:r>
+          </a:p>
+          <a:p>
+            <a:pPr>
+              <a:spcAft>
+                <a:spcPts val="800"/>
+              </a:spcAft>
+              <a:defRPr b="1" sz="1100">
+                <a:solidFill>
+                  <a:srgbClr val="0F172A"/>
+                </a:solidFill>
+              </a:defRPr>
+            </a:pPr>
+            <a:r>
+              <a:t>- Link injection: </a:t>
+            </a:r>
+            <a:r>
+              <a:rPr b="0">
+                <a:solidFill>
+                  <a:srgbClr val="334155"/>
+                </a:solidFill>
+              </a:rPr>
+              <a:t>javascript: URLs in deliverables. Fixed: only http(s) become links.</a:t>
+            </a:r>
+          </a:p>
+          <a:p>
+            <a:pPr>
+              <a:spcAft>
+                <a:spcPts val="800"/>
+              </a:spcAft>
+              <a:defRPr b="1" sz="1100">
+                <a:solidFill>
+                  <a:srgbClr val="0F172A"/>
+                </a:solidFill>
+              </a:defRPr>
+            </a:pPr>
+            <a:r>
+              <a:t>- Silent failures: </a:t>
+            </a:r>
+            <a:r>
+              <a:rPr b="0">
+                <a:solidFill>
+                  <a:srgbClr val="334155"/>
+                </a:solidFill>
+              </a:rPr>
+              <a:t>blank pages on network loss. Fixed: loadFailed() banners everywhere.</a:t>
+            </a:r>
+          </a:p>
+        </p:txBody>
+      </p:sp>
+      <p:sp>
+        <p:nvSpPr>
+          <p:cNvPr id="7" name="Rounded Rectangle 6"/>
+          <p:cNvSpPr/>
+          <p:nvPr/>
+        </p:nvSpPr>
+        <p:spPr>
+          <a:xfrm>
+            <a:off x="6217920" y="1371600"/>
+            <a:ext cx="5212080" cy="4937760"/>
+          </a:xfrm>
+          <a:prstGeom prst="roundRect">
+            <a:avLst/>
+          </a:prstGeom>
+          <a:solidFill>
+            <a:srgbClr val="FFFFFF"/>
+          </a:solidFill>
+          <a:ln w="12700">
+            <a:solidFill>
+              <a:srgbClr val="E2E8F0"/>
+            </a:solidFill>
+          </a:ln>
+        </p:spPr>
+        <p:style>
+          <a:lnRef idx="1">
+            <a:schemeClr val="accent1"/>
+          </a:lnRef>
+          <a:fillRef idx="3">
+            <a:schemeClr val="accent1"/>
+          </a:fillRef>
+          <a:effectRef idx="2">
+            <a:schemeClr val="accent1"/>
+          </a:effectRef>
+          <a:fontRef idx="minor">
+            <a:schemeClr val="lt1"/>
+          </a:fontRef>
+        </p:style>
+        <p:txBody>
+          <a:bodyPr rtlCol="0" anchor="ctr"/>
+          <a:lstStyle/>
+          <a:p>
+            <a:pPr algn="ctr"/>
+          </a:p>
+        </p:txBody>
+      </p:sp>
+      <p:sp>
+        <p:nvSpPr>
+          <p:cNvPr id="8" name="TextBox 7"/>
+          <p:cNvSpPr txBox="1"/>
+          <p:nvPr/>
+        </p:nvSpPr>
+        <p:spPr>
+          <a:xfrm>
+            <a:off x="6400800" y="1508760"/>
+            <a:ext cx="4846320" cy="411480"/>
+          </a:xfrm>
+          <a:prstGeom prst="rect">
+            <a:avLst/>
+          </a:prstGeom>
+          <a:noFill/>
+        </p:spPr>
+        <p:txBody>
+          <a:bodyPr wrap="none">
+            <a:spAutoFit/>
+          </a:bodyPr>
+          <a:lstStyle/>
+          <a:p>
+            <a:pPr>
+              <a:defRPr sz="1300" b="1">
+                <a:solidFill>
+                  <a:srgbClr val="0F172A"/>
+                </a:solidFill>
+              </a:defRPr>
+            </a:pPr>
+            <a:r>
+              <a:t>Empirical Verification</a:t>
+            </a:r>
+          </a:p>
+        </p:txBody>
+      </p:sp>
+      <p:sp>
+        <p:nvSpPr>
+          <p:cNvPr id="9" name="TextBox 8"/>
+          <p:cNvSpPr txBox="1"/>
+          <p:nvPr/>
+        </p:nvSpPr>
+        <p:spPr>
+          <a:xfrm>
+            <a:off x="6400800" y="1965960"/>
+            <a:ext cx="4846320" cy="4206240"/>
+          </a:xfrm>
+          <a:prstGeom prst="rect">
+            <a:avLst/>
+          </a:prstGeom>
+          <a:noFill/>
+        </p:spPr>
+        <p:txBody>
+          <a:bodyPr wrap="square">
+            <a:spAutoFit/>
+          </a:bodyPr>
+          <a:lstStyle/>
+          <a:p>
+            <a:pPr>
+              <a:spcAft>
+                <a:spcPts val="800"/>
+              </a:spcAft>
+              <a:defRPr b="1" sz="1100">
+                <a:solidFill>
+                  <a:srgbClr val="16A34A"/>
+                </a:solidFill>
+              </a:defRPr>
+            </a:pPr>
+            <a:r>
+              <a:t>+ 40/40 functional: </a:t>
+            </a:r>
+            <a:r>
+              <a:rPr b="0">
+                <a:solidFill>
+                  <a:srgbClr val="334155"/>
+                </a:solidFill>
+              </a:rPr>
+              <a:t>composition, duplicates, countdowns, exports all pass.</a:t>
+            </a:r>
+          </a:p>
+          <a:p>
+            <a:pPr>
+              <a:spcAft>
+                <a:spcPts val="800"/>
+              </a:spcAft>
+              <a:defRPr b="1" sz="1100">
+                <a:solidFill>
+                  <a:srgbClr val="16A34A"/>
+                </a:solidFill>
+              </a:defRPr>
+            </a:pPr>
+            <a:r>
+              <a:t>+ 27/27 stress: </a:t>
+            </a:r>
+            <a:r>
+              <a:rPr b="0">
+                <a:solidFill>
+                  <a:srgbClr val="334155"/>
+                </a:solidFill>
+              </a:rPr>
+              <a:t>200 GETs in 447ms (~450/s); 50 concurrent in 77ms, zero failures.</a:t>
+            </a:r>
+          </a:p>
+          <a:p>
+            <a:pPr>
+              <a:spcAft>
+                <a:spcPts val="800"/>
+              </a:spcAft>
+              <a:defRPr b="1" sz="1100">
+                <a:solidFill>
+                  <a:srgbClr val="16A34A"/>
+                </a:solidFill>
+              </a:defRPr>
+            </a:pPr>
+            <a:r>
+              <a:t>+ Parallel writes: </a:t>
+            </a:r>
+            <a:r>
+              <a:rPr b="0">
+                <a:solidFill>
+                  <a:srgbClr val="334155"/>
+                </a:solidFill>
+              </a:rPr>
+              <a:t>10 simultaneous team creates, no races or id collisions.</a:t>
+            </a:r>
+          </a:p>
+          <a:p>
+            <a:pPr>
+              <a:spcAft>
+                <a:spcPts val="800"/>
+              </a:spcAft>
+              <a:defRPr b="1" sz="1100">
+                <a:solidFill>
+                  <a:srgbClr val="16A34A"/>
+                </a:solidFill>
+              </a:defRPr>
+            </a:pPr>
+            <a:r>
+              <a:t>+ 38/38 browser: </a:t>
+            </a:r>
+            <a:r>
+              <a:rPr b="0">
+                <a:solidFill>
+                  <a:srgbClr val="334155"/>
+                </a:solidFill>
+              </a:rPr>
+              <a:t>headless Chrome at 390px + 1280px, no errors, no overflow.</a:t>
             </a:r>
           </a:p>
         </p:txBody>
@@ -3462,52 +5824,586 @@
       <p:grpSpPr/>
       <p:sp>
         <p:nvSpPr>
-          <p:cNvPr id="2" name="Title 1"/>
-          <p:cNvSpPr>
-            <a:spLocks noGrp="1"/>
-          </p:cNvSpPr>
-          <p:nvPr>
-            <p:ph type="title"/>
-          </p:nvPr>
-        </p:nvSpPr>
-        <p:spPr/>
-        <p:txBody>
-          <a:bodyPr/>
-          <a:lstStyle/>
-          <a:p>
-            <a:r>
-              <a:t>Key logic</a:t>
-            </a:r>
-          </a:p>
-        </p:txBody>
-      </p:sp>
-      <p:sp>
-        <p:nvSpPr>
-          <p:cNvPr id="3" name="Content Placeholder 2"/>
-          <p:cNvSpPr>
-            <a:spLocks noGrp="1"/>
-          </p:cNvSpPr>
-          <p:nvPr>
-            <p:ph idx="1"/>
-          </p:nvPr>
-        </p:nvSpPr>
-        <p:spPr/>
-        <p:txBody>
-          <a:bodyPr/>
-          <a:lstStyle/>
-          <a:p>
-            <a:r>
-              <a:t>checkComposition(): exactly 6 + 1 female, 400 block</a:t>
-            </a:r>
-          </a:p>
-          <a:p>
-            <a:r>
-              <a:t>readiness(): approved/4*100 - 25 (bad team) - 25 (no mentor)</a:t>
-            </a:r>
-          </a:p>
-          <a:p>
-            <a:r>
-              <a:t>QA found seed-id bug, fixed, 14/14 pass</a:t>
+          <p:cNvPr id="2" name="TextBox 1"/>
+          <p:cNvSpPr txBox="1"/>
+          <p:nvPr/>
+        </p:nvSpPr>
+        <p:spPr>
+          <a:xfrm>
+            <a:off x="731520" y="320040"/>
+            <a:ext cx="10698480" cy="320040"/>
+          </a:xfrm>
+          <a:prstGeom prst="rect">
+            <a:avLst/>
+          </a:prstGeom>
+          <a:noFill/>
+        </p:spPr>
+        <p:txBody>
+          <a:bodyPr wrap="none">
+            <a:spAutoFit/>
+          </a:bodyPr>
+          <a:lstStyle/>
+          <a:p>
+            <a:pPr>
+              <a:defRPr sz="1000" b="1">
+                <a:solidFill>
+                  <a:srgbClr val="2563EB"/>
+                </a:solidFill>
+              </a:defRPr>
+            </a:pPr>
+            <a:r>
+              <a:t>SIH COMMAND CENTER | PBL 14</a:t>
+            </a:r>
+          </a:p>
+        </p:txBody>
+      </p:sp>
+      <p:sp>
+        <p:nvSpPr>
+          <p:cNvPr id="3" name="TextBox 2"/>
+          <p:cNvSpPr txBox="1"/>
+          <p:nvPr/>
+        </p:nvSpPr>
+        <p:spPr>
+          <a:xfrm>
+            <a:off x="731520" y="621792"/>
+            <a:ext cx="10698480" cy="640080"/>
+          </a:xfrm>
+          <a:prstGeom prst="rect">
+            <a:avLst/>
+          </a:prstGeom>
+          <a:noFill/>
+        </p:spPr>
+        <p:txBody>
+          <a:bodyPr wrap="none">
+            <a:spAutoFit/>
+          </a:bodyPr>
+          <a:lstStyle/>
+          <a:p>
+            <a:pPr>
+              <a:defRPr sz="2200" b="1">
+                <a:solidFill>
+                  <a:srgbClr val="0F172A"/>
+                </a:solidFill>
+              </a:defRPr>
+            </a:pPr>
+            <a:r>
+              <a:t>Future Roadmap: Production Scaling &amp; Advanced Capabilities</a:t>
+            </a:r>
+          </a:p>
+        </p:txBody>
+      </p:sp>
+      <p:sp>
+        <p:nvSpPr>
+          <p:cNvPr id="4" name="Rounded Rectangle 3"/>
+          <p:cNvSpPr/>
+          <p:nvPr/>
+        </p:nvSpPr>
+        <p:spPr>
+          <a:xfrm>
+            <a:off x="731520" y="1371600"/>
+            <a:ext cx="3383280" cy="4937760"/>
+          </a:xfrm>
+          <a:prstGeom prst="roundRect">
+            <a:avLst/>
+          </a:prstGeom>
+          <a:solidFill>
+            <a:srgbClr val="FFFFFF"/>
+          </a:solidFill>
+          <a:ln w="12700">
+            <a:solidFill>
+              <a:srgbClr val="E2E8F0"/>
+            </a:solidFill>
+          </a:ln>
+        </p:spPr>
+        <p:style>
+          <a:lnRef idx="1">
+            <a:schemeClr val="accent1"/>
+          </a:lnRef>
+          <a:fillRef idx="3">
+            <a:schemeClr val="accent1"/>
+          </a:fillRef>
+          <a:effectRef idx="2">
+            <a:schemeClr val="accent1"/>
+          </a:effectRef>
+          <a:fontRef idx="minor">
+            <a:schemeClr val="lt1"/>
+          </a:fontRef>
+        </p:style>
+        <p:txBody>
+          <a:bodyPr rtlCol="0" anchor="ctr"/>
+          <a:lstStyle/>
+          <a:p>
+            <a:pPr algn="ctr"/>
+          </a:p>
+        </p:txBody>
+      </p:sp>
+      <p:sp>
+        <p:nvSpPr>
+          <p:cNvPr id="5" name="TextBox 4"/>
+          <p:cNvSpPr txBox="1"/>
+          <p:nvPr/>
+        </p:nvSpPr>
+        <p:spPr>
+          <a:xfrm>
+            <a:off x="914400" y="1508760"/>
+            <a:ext cx="3017520" cy="411480"/>
+          </a:xfrm>
+          <a:prstGeom prst="rect">
+            <a:avLst/>
+          </a:prstGeom>
+          <a:noFill/>
+        </p:spPr>
+        <p:txBody>
+          <a:bodyPr wrap="none">
+            <a:spAutoFit/>
+          </a:bodyPr>
+          <a:lstStyle/>
+          <a:p>
+            <a:pPr>
+              <a:defRPr sz="1300" b="1">
+                <a:solidFill>
+                  <a:srgbClr val="0F172A"/>
+                </a:solidFill>
+              </a:defRPr>
+            </a:pPr>
+            <a:r>
+              <a:t>Phase 1: Security &amp; Identity</a:t>
+            </a:r>
+          </a:p>
+        </p:txBody>
+      </p:sp>
+      <p:sp>
+        <p:nvSpPr>
+          <p:cNvPr id="6" name="TextBox 5"/>
+          <p:cNvSpPr txBox="1"/>
+          <p:nvPr/>
+        </p:nvSpPr>
+        <p:spPr>
+          <a:xfrm>
+            <a:off x="914400" y="1965960"/>
+            <a:ext cx="3017520" cy="4206240"/>
+          </a:xfrm>
+          <a:prstGeom prst="rect">
+            <a:avLst/>
+          </a:prstGeom>
+          <a:noFill/>
+        </p:spPr>
+        <p:txBody>
+          <a:bodyPr wrap="square">
+            <a:spAutoFit/>
+          </a:bodyPr>
+          <a:lstStyle/>
+          <a:p>
+            <a:pPr>
+              <a:spcAft>
+                <a:spcPts val="800"/>
+              </a:spcAft>
+              <a:defRPr b="1" sz="1100">
+                <a:solidFill>
+                  <a:srgbClr val="0F172A"/>
+                </a:solidFill>
+              </a:defRPr>
+            </a:pPr>
+            <a:r>
+              <a:t>- RBAC: </a:t>
+            </a:r>
+            <a:r>
+              <a:rPr b="0">
+                <a:solidFill>
+                  <a:srgbClr val="334155"/>
+                </a:solidFill>
+              </a:rPr>
+              <a:t>SPOC admin, mentors, team leads with JWT sessions.</a:t>
+            </a:r>
+          </a:p>
+          <a:p>
+            <a:pPr>
+              <a:spcAft>
+                <a:spcPts val="800"/>
+              </a:spcAft>
+              <a:defRPr b="1" sz="1100">
+                <a:solidFill>
+                  <a:srgbClr val="0F172A"/>
+                </a:solidFill>
+              </a:defRPr>
+            </a:pPr>
+            <a:r>
+              <a:t>- SSO: </a:t>
+            </a:r>
+            <a:r>
+              <a:rPr b="0">
+                <a:solidFill>
+                  <a:srgbClr val="334155"/>
+                </a:solidFill>
+              </a:rPr>
+              <a:t>OAuth bridge with campus Microsoft 365 directory.</a:t>
+            </a:r>
+          </a:p>
+          <a:p>
+            <a:pPr>
+              <a:spcAft>
+                <a:spcPts val="800"/>
+              </a:spcAft>
+              <a:defRPr b="1" sz="1100">
+                <a:solidFill>
+                  <a:srgbClr val="0F172A"/>
+                </a:solidFill>
+              </a:defRPr>
+            </a:pPr>
+            <a:r>
+              <a:t>- Audit trails: </a:t>
+            </a:r>
+            <a:r>
+              <a:rPr b="0">
+                <a:solidFill>
+                  <a:srgbClr val="334155"/>
+                </a:solidFill>
+              </a:rPr>
+              <a:t>immutable log of approvals and edits.</a:t>
+            </a:r>
+          </a:p>
+        </p:txBody>
+      </p:sp>
+      <p:sp>
+        <p:nvSpPr>
+          <p:cNvPr id="7" name="Rounded Rectangle 6"/>
+          <p:cNvSpPr/>
+          <p:nvPr/>
+        </p:nvSpPr>
+        <p:spPr>
+          <a:xfrm>
+            <a:off x="4389120" y="1371600"/>
+            <a:ext cx="3383280" cy="4937760"/>
+          </a:xfrm>
+          <a:prstGeom prst="roundRect">
+            <a:avLst/>
+          </a:prstGeom>
+          <a:solidFill>
+            <a:srgbClr val="FFFFFF"/>
+          </a:solidFill>
+          <a:ln w="12700">
+            <a:solidFill>
+              <a:srgbClr val="E2E8F0"/>
+            </a:solidFill>
+          </a:ln>
+        </p:spPr>
+        <p:style>
+          <a:lnRef idx="1">
+            <a:schemeClr val="accent1"/>
+          </a:lnRef>
+          <a:fillRef idx="3">
+            <a:schemeClr val="accent1"/>
+          </a:fillRef>
+          <a:effectRef idx="2">
+            <a:schemeClr val="accent1"/>
+          </a:effectRef>
+          <a:fontRef idx="minor">
+            <a:schemeClr val="lt1"/>
+          </a:fontRef>
+        </p:style>
+        <p:txBody>
+          <a:bodyPr rtlCol="0" anchor="ctr"/>
+          <a:lstStyle/>
+          <a:p>
+            <a:pPr algn="ctr"/>
+          </a:p>
+        </p:txBody>
+      </p:sp>
+      <p:sp>
+        <p:nvSpPr>
+          <p:cNvPr id="8" name="TextBox 7"/>
+          <p:cNvSpPr txBox="1"/>
+          <p:nvPr/>
+        </p:nvSpPr>
+        <p:spPr>
+          <a:xfrm>
+            <a:off x="4572000" y="1508760"/>
+            <a:ext cx="3017520" cy="411480"/>
+          </a:xfrm>
+          <a:prstGeom prst="rect">
+            <a:avLst/>
+          </a:prstGeom>
+          <a:noFill/>
+        </p:spPr>
+        <p:txBody>
+          <a:bodyPr wrap="none">
+            <a:spAutoFit/>
+          </a:bodyPr>
+          <a:lstStyle/>
+          <a:p>
+            <a:pPr>
+              <a:defRPr sz="1300" b="1">
+                <a:solidFill>
+                  <a:srgbClr val="0F172A"/>
+                </a:solidFill>
+              </a:defRPr>
+            </a:pPr>
+            <a:r>
+              <a:t>Phase 2: Communication</a:t>
+            </a:r>
+          </a:p>
+        </p:txBody>
+      </p:sp>
+      <p:sp>
+        <p:nvSpPr>
+          <p:cNvPr id="9" name="TextBox 8"/>
+          <p:cNvSpPr txBox="1"/>
+          <p:nvPr/>
+        </p:nvSpPr>
+        <p:spPr>
+          <a:xfrm>
+            <a:off x="4572000" y="1965960"/>
+            <a:ext cx="3017520" cy="4206240"/>
+          </a:xfrm>
+          <a:prstGeom prst="rect">
+            <a:avLst/>
+          </a:prstGeom>
+          <a:noFill/>
+        </p:spPr>
+        <p:txBody>
+          <a:bodyPr wrap="square">
+            <a:spAutoFit/>
+          </a:bodyPr>
+          <a:lstStyle/>
+          <a:p>
+            <a:pPr>
+              <a:spcAft>
+                <a:spcPts val="800"/>
+              </a:spcAft>
+              <a:defRPr b="1" sz="1100">
+                <a:solidFill>
+                  <a:srgbClr val="0F172A"/>
+                </a:solidFill>
+              </a:defRPr>
+            </a:pPr>
+            <a:r>
+              <a:t>- Email alerts: </a:t>
+            </a:r>
+            <a:r>
+              <a:rPr b="0">
+                <a:solidFill>
+                  <a:srgbClr val="334155"/>
+                </a:solidFill>
+              </a:rPr>
+              <a:t>SMTP notices on revision flags.</a:t>
+            </a:r>
+          </a:p>
+          <a:p>
+            <a:pPr>
+              <a:spcAft>
+                <a:spcPts val="800"/>
+              </a:spcAft>
+              <a:defRPr b="1" sz="1100">
+                <a:solidFill>
+                  <a:srgbClr val="0F172A"/>
+                </a:solidFill>
+              </a:defRPr>
+            </a:pPr>
+            <a:r>
+              <a:t>- WhatsApp pushes: </a:t>
+            </a:r>
+            <a:r>
+              <a:rPr b="0">
+                <a:solidFill>
+                  <a:srgbClr val="334155"/>
+                </a:solidFill>
+              </a:rPr>
+              <a:t>deadline countdowns to team leads.</a:t>
+            </a:r>
+          </a:p>
+          <a:p>
+            <a:pPr>
+              <a:spcAft>
+                <a:spcPts val="800"/>
+              </a:spcAft>
+              <a:defRPr b="1" sz="1100">
+                <a:solidFill>
+                  <a:srgbClr val="0F172A"/>
+                </a:solidFill>
+              </a:defRPr>
+            </a:pPr>
+            <a:r>
+              <a:t>- Review portals: </a:t>
+            </a:r>
+            <a:r>
+              <a:rPr b="0">
+                <a:solidFill>
+                  <a:srgbClr val="334155"/>
+                </a:solidFill>
+              </a:rPr>
+              <a:t>one-click approve links in mentor mail.</a:t>
+            </a:r>
+          </a:p>
+        </p:txBody>
+      </p:sp>
+      <p:sp>
+        <p:nvSpPr>
+          <p:cNvPr id="10" name="Rounded Rectangle 9"/>
+          <p:cNvSpPr/>
+          <p:nvPr/>
+        </p:nvSpPr>
+        <p:spPr>
+          <a:xfrm>
+            <a:off x="8046720" y="1371600"/>
+            <a:ext cx="3383280" cy="4937760"/>
+          </a:xfrm>
+          <a:prstGeom prst="roundRect">
+            <a:avLst/>
+          </a:prstGeom>
+          <a:solidFill>
+            <a:srgbClr val="FFFFFF"/>
+          </a:solidFill>
+          <a:ln w="12700">
+            <a:solidFill>
+              <a:srgbClr val="E2E8F0"/>
+            </a:solidFill>
+          </a:ln>
+        </p:spPr>
+        <p:style>
+          <a:lnRef idx="1">
+            <a:schemeClr val="accent1"/>
+          </a:lnRef>
+          <a:fillRef idx="3">
+            <a:schemeClr val="accent1"/>
+          </a:fillRef>
+          <a:effectRef idx="2">
+            <a:schemeClr val="accent1"/>
+          </a:effectRef>
+          <a:fontRef idx="minor">
+            <a:schemeClr val="lt1"/>
+          </a:fontRef>
+        </p:style>
+        <p:txBody>
+          <a:bodyPr rtlCol="0" anchor="ctr"/>
+          <a:lstStyle/>
+          <a:p>
+            <a:pPr algn="ctr"/>
+          </a:p>
+        </p:txBody>
+      </p:sp>
+      <p:sp>
+        <p:nvSpPr>
+          <p:cNvPr id="11" name="TextBox 10"/>
+          <p:cNvSpPr txBox="1"/>
+          <p:nvPr/>
+        </p:nvSpPr>
+        <p:spPr>
+          <a:xfrm>
+            <a:off x="8229600" y="1508760"/>
+            <a:ext cx="3017520" cy="411480"/>
+          </a:xfrm>
+          <a:prstGeom prst="rect">
+            <a:avLst/>
+          </a:prstGeom>
+          <a:noFill/>
+        </p:spPr>
+        <p:txBody>
+          <a:bodyPr wrap="none">
+            <a:spAutoFit/>
+          </a:bodyPr>
+          <a:lstStyle/>
+          <a:p>
+            <a:pPr>
+              <a:defRPr sz="1300" b="1">
+                <a:solidFill>
+                  <a:srgbClr val="0F172A"/>
+                </a:solidFill>
+              </a:defRPr>
+            </a:pPr>
+            <a:r>
+              <a:t>Phase 3: Data &amp; Cloud</a:t>
+            </a:r>
+          </a:p>
+        </p:txBody>
+      </p:sp>
+      <p:sp>
+        <p:nvSpPr>
+          <p:cNvPr id="12" name="TextBox 11"/>
+          <p:cNvSpPr txBox="1"/>
+          <p:nvPr/>
+        </p:nvSpPr>
+        <p:spPr>
+          <a:xfrm>
+            <a:off x="8229600" y="1965960"/>
+            <a:ext cx="3017520" cy="4206240"/>
+          </a:xfrm>
+          <a:prstGeom prst="rect">
+            <a:avLst/>
+          </a:prstGeom>
+          <a:noFill/>
+        </p:spPr>
+        <p:txBody>
+          <a:bodyPr wrap="square">
+            <a:spAutoFit/>
+          </a:bodyPr>
+          <a:lstStyle/>
+          <a:p>
+            <a:pPr>
+              <a:spcAft>
+                <a:spcPts val="800"/>
+              </a:spcAft>
+              <a:defRPr b="1" sz="1100">
+                <a:solidFill>
+                  <a:srgbClr val="0F172A"/>
+                </a:solidFill>
+              </a:defRPr>
+            </a:pPr>
+            <a:r>
+              <a:t>- Postgres: </a:t>
+            </a:r>
+            <a:r>
+              <a:rPr b="0">
+                <a:solidFill>
+                  <a:srgbClr val="334155"/>
+                </a:solidFill>
+              </a:rPr>
+              <a:t>relational schema via Prisma ORM.</a:t>
+            </a:r>
+          </a:p>
+          <a:p>
+            <a:pPr>
+              <a:spcAft>
+                <a:spcPts val="800"/>
+              </a:spcAft>
+              <a:defRPr b="1" sz="1100">
+                <a:solidFill>
+                  <a:srgbClr val="0F172A"/>
+                </a:solidFill>
+              </a:defRPr>
+            </a:pPr>
+            <a:r>
+              <a:t>- Artifact storage: </a:t>
+            </a:r>
+            <a:r>
+              <a:rPr b="0">
+                <a:solidFill>
+                  <a:srgbClr val="334155"/>
+                </a:solidFill>
+              </a:rPr>
+              <a:t>S3/R2 buckets + GitHub verification.</a:t>
+            </a:r>
+          </a:p>
+          <a:p>
+            <a:pPr>
+              <a:spcAft>
+                <a:spcPts val="800"/>
+              </a:spcAft>
+              <a:defRPr b="1" sz="1100">
+                <a:solidFill>
+                  <a:srgbClr val="0F172A"/>
+                </a:solidFill>
+              </a:defRPr>
+            </a:pPr>
+            <a:r>
+              <a:t>- Coolify deploy: </a:t>
+            </a:r>
+            <a:r>
+              <a:rPr b="0">
+                <a:solidFill>
+                  <a:srgbClr val="334155"/>
+                </a:solidFill>
+              </a:rPr>
+              <a:t>Docker + health checks + snapshots.</a:t>
             </a:r>
           </a:p>
         </p:txBody>
@@ -3532,52 +6428,506 @@
       <p:grpSpPr/>
       <p:sp>
         <p:nvSpPr>
-          <p:cNvPr id="2" name="Title 1"/>
-          <p:cNvSpPr>
-            <a:spLocks noGrp="1"/>
-          </p:cNvSpPr>
-          <p:nvPr>
-            <p:ph type="title"/>
-          </p:nvPr>
-        </p:nvSpPr>
-        <p:spPr/>
-        <p:txBody>
-          <a:bodyPr/>
-          <a:lstStyle/>
-          <a:p>
-            <a:r>
-              <a:t>Testing</a:t>
-            </a:r>
-          </a:p>
-        </p:txBody>
-      </p:sp>
-      <p:sp>
-        <p:nvSpPr>
-          <p:cNvPr id="3" name="Content Placeholder 2"/>
-          <p:cNvSpPr>
-            <a:spLocks noGrp="1"/>
-          </p:cNvSpPr>
-          <p:nvPr>
-            <p:ph idx="1"/>
-          </p:nvPr>
-        </p:nvSpPr>
-        <p:spPr/>
-        <p:txBody>
-          <a:bodyPr/>
-          <a:lstStyle/>
-          <a:p>
-            <a:r>
-              <a:t>17 manual cases, all pass.</a:t>
-            </a:r>
-          </a:p>
-          <a:p>
-            <a:r>
-              <a:t>2 bugs fixed (CSV quotes, seed ids).</a:t>
-            </a:r>
-          </a:p>
-          <a:p>
-            <a:r>
-              <a:t>Known minor: dashboard filters reset on reload.</a:t>
+          <p:cNvPr id="2" name="TextBox 1"/>
+          <p:cNvSpPr txBox="1"/>
+          <p:nvPr/>
+        </p:nvSpPr>
+        <p:spPr>
+          <a:xfrm>
+            <a:off x="731520" y="320040"/>
+            <a:ext cx="10698480" cy="320040"/>
+          </a:xfrm>
+          <a:prstGeom prst="rect">
+            <a:avLst/>
+          </a:prstGeom>
+          <a:noFill/>
+        </p:spPr>
+        <p:txBody>
+          <a:bodyPr wrap="none">
+            <a:spAutoFit/>
+          </a:bodyPr>
+          <a:lstStyle/>
+          <a:p>
+            <a:pPr>
+              <a:defRPr sz="1000" b="1">
+                <a:solidFill>
+                  <a:srgbClr val="2563EB"/>
+                </a:solidFill>
+              </a:defRPr>
+            </a:pPr>
+            <a:r>
+              <a:t>SIH COMMAND CENTER | PBL 14</a:t>
+            </a:r>
+          </a:p>
+        </p:txBody>
+      </p:sp>
+      <p:sp>
+        <p:nvSpPr>
+          <p:cNvPr id="3" name="TextBox 2"/>
+          <p:cNvSpPr txBox="1"/>
+          <p:nvPr/>
+        </p:nvSpPr>
+        <p:spPr>
+          <a:xfrm>
+            <a:off x="731520" y="621792"/>
+            <a:ext cx="10698480" cy="640080"/>
+          </a:xfrm>
+          <a:prstGeom prst="rect">
+            <a:avLst/>
+          </a:prstGeom>
+          <a:noFill/>
+        </p:spPr>
+        <p:txBody>
+          <a:bodyPr wrap="none">
+            <a:spAutoFit/>
+          </a:bodyPr>
+          <a:lstStyle/>
+          <a:p>
+            <a:pPr>
+              <a:defRPr sz="2200" b="1">
+                <a:solidFill>
+                  <a:srgbClr val="0F172A"/>
+                </a:solidFill>
+              </a:defRPr>
+            </a:pPr>
+            <a:r>
+              <a:t>Viva Defense &amp; Live Demonstration Runbook</a:t>
+            </a:r>
+          </a:p>
+        </p:txBody>
+      </p:sp>
+      <p:sp>
+        <p:nvSpPr>
+          <p:cNvPr id="4" name="Rounded Rectangle 3"/>
+          <p:cNvSpPr/>
+          <p:nvPr/>
+        </p:nvSpPr>
+        <p:spPr>
+          <a:xfrm>
+            <a:off x="731520" y="1371600"/>
+            <a:ext cx="5120640" cy="4937760"/>
+          </a:xfrm>
+          <a:prstGeom prst="roundRect">
+            <a:avLst/>
+          </a:prstGeom>
+          <a:solidFill>
+            <a:srgbClr val="FFFFFF"/>
+          </a:solidFill>
+          <a:ln w="12700">
+            <a:solidFill>
+              <a:srgbClr val="E2E8F0"/>
+            </a:solidFill>
+          </a:ln>
+        </p:spPr>
+        <p:style>
+          <a:lnRef idx="1">
+            <a:schemeClr val="accent1"/>
+          </a:lnRef>
+          <a:fillRef idx="3">
+            <a:schemeClr val="accent1"/>
+          </a:fillRef>
+          <a:effectRef idx="2">
+            <a:schemeClr val="accent1"/>
+          </a:effectRef>
+          <a:fontRef idx="minor">
+            <a:schemeClr val="lt1"/>
+          </a:fontRef>
+        </p:style>
+        <p:txBody>
+          <a:bodyPr rtlCol="0" anchor="ctr"/>
+          <a:lstStyle/>
+          <a:p>
+            <a:pPr algn="ctr"/>
+          </a:p>
+        </p:txBody>
+      </p:sp>
+      <p:sp>
+        <p:nvSpPr>
+          <p:cNvPr id="5" name="TextBox 4"/>
+          <p:cNvSpPr txBox="1"/>
+          <p:nvPr/>
+        </p:nvSpPr>
+        <p:spPr>
+          <a:xfrm>
+            <a:off x="914400" y="1508760"/>
+            <a:ext cx="4754880" cy="411480"/>
+          </a:xfrm>
+          <a:prstGeom prst="rect">
+            <a:avLst/>
+          </a:prstGeom>
+          <a:noFill/>
+        </p:spPr>
+        <p:txBody>
+          <a:bodyPr wrap="none">
+            <a:spAutoFit/>
+          </a:bodyPr>
+          <a:lstStyle/>
+          <a:p>
+            <a:pPr>
+              <a:defRPr sz="1300" b="1">
+                <a:solidFill>
+                  <a:srgbClr val="0F172A"/>
+                </a:solidFill>
+              </a:defRPr>
+            </a:pPr>
+            <a:r>
+              <a:t>Live 3-Minute Demo Sequence</a:t>
+            </a:r>
+          </a:p>
+        </p:txBody>
+      </p:sp>
+      <p:sp>
+        <p:nvSpPr>
+          <p:cNvPr id="6" name="TextBox 5"/>
+          <p:cNvSpPr txBox="1"/>
+          <p:nvPr/>
+        </p:nvSpPr>
+        <p:spPr>
+          <a:xfrm>
+            <a:off x="914400" y="1965960"/>
+            <a:ext cx="4754880" cy="4206240"/>
+          </a:xfrm>
+          <a:prstGeom prst="rect">
+            <a:avLst/>
+          </a:prstGeom>
+          <a:noFill/>
+        </p:spPr>
+        <p:txBody>
+          <a:bodyPr wrap="square">
+            <a:spAutoFit/>
+          </a:bodyPr>
+          <a:lstStyle/>
+          <a:p>
+            <a:pPr>
+              <a:spcAft>
+                <a:spcPts val="800"/>
+              </a:spcAft>
+              <a:defRPr b="1" sz="1100">
+                <a:solidFill>
+                  <a:srgbClr val="0F172A"/>
+                </a:solidFill>
+              </a:defRPr>
+            </a:pPr>
+            <a:r>
+              <a:t>- 1. Rejection: </a:t>
+            </a:r>
+            <a:r>
+              <a:rPr b="0">
+                <a:solidFill>
+                  <a:srgbClr val="334155"/>
+                </a:solidFill>
+              </a:rPr>
+              <a:t>submit 5-member team, show HTTP 400 block.</a:t>
+            </a:r>
+          </a:p>
+          <a:p>
+            <a:pPr>
+              <a:spcAft>
+                <a:spcPts val="800"/>
+              </a:spcAft>
+              <a:defRPr b="1" sz="1100">
+                <a:solidFill>
+                  <a:srgbClr val="0F172A"/>
+                </a:solidFill>
+              </a:defRPr>
+            </a:pPr>
+            <a:r>
+              <a:t>- 2. Happy path: </a:t>
+            </a:r>
+            <a:r>
+              <a:rPr b="0">
+                <a:solidFill>
+                  <a:srgbClr val="334155"/>
+                </a:solidFill>
+              </a:rPr>
+              <a:t>register valid team, wizard reaches Done.</a:t>
+            </a:r>
+          </a:p>
+          <a:p>
+            <a:pPr>
+              <a:spcAft>
+                <a:spcPts val="800"/>
+              </a:spcAft>
+              <a:defRPr b="1" sz="1100">
+                <a:solidFill>
+                  <a:srgbClr val="0F172A"/>
+                </a:solidFill>
+              </a:defRPr>
+            </a:pPr>
+            <a:r>
+              <a:t>- 3. Duplicate guard: </a:t>
+            </a:r>
+            <a:r>
+              <a:rPr b="0">
+                <a:solidFill>
+                  <a:srgbClr val="334155"/>
+                </a:solidFill>
+              </a:rPr>
+              <a:t>claim taken PS, then allowDuplicate override.</a:t>
+            </a:r>
+          </a:p>
+          <a:p>
+            <a:pPr>
+              <a:spcAft>
+                <a:spcPts val="800"/>
+              </a:spcAft>
+              <a:defRPr b="1" sz="1100">
+                <a:solidFill>
+                  <a:srgbClr val="0F172A"/>
+                </a:solidFill>
+              </a:defRPr>
+            </a:pPr>
+            <a:r>
+              <a:t>- 4. Auto-mentor: </a:t>
+            </a:r>
+            <a:r>
+              <a:rPr b="0">
+                <a:solidFill>
+                  <a:srgbClr val="334155"/>
+                </a:solidFill>
+              </a:rPr>
+              <a:t>least-loaded assignment on mentors page.</a:t>
+            </a:r>
+          </a:p>
+          <a:p>
+            <a:pPr>
+              <a:spcAft>
+                <a:spcPts val="800"/>
+              </a:spcAft>
+              <a:defRPr b="1" sz="1100">
+                <a:solidFill>
+                  <a:srgbClr val="0F172A"/>
+                </a:solidFill>
+              </a:defRPr>
+            </a:pPr>
+            <a:r>
+              <a:t>- 5. Readiness climb: </a:t>
+            </a:r>
+            <a:r>
+              <a:rPr b="0">
+                <a:solidFill>
+                  <a:srgbClr val="334155"/>
+                </a:solidFill>
+              </a:rPr>
+              <a:t>approve 2 items, watch score rise.</a:t>
+            </a:r>
+          </a:p>
+          <a:p>
+            <a:pPr>
+              <a:spcAft>
+                <a:spcPts val="800"/>
+              </a:spcAft>
+              <a:defRPr b="1" sz="1100">
+                <a:solidFill>
+                  <a:srgbClr val="0F172A"/>
+                </a:solidFill>
+              </a:defRPr>
+            </a:pPr>
+            <a:r>
+              <a:t>- 6. Export: </a:t>
+            </a:r>
+            <a:r>
+              <a:rPr b="0">
+                <a:solidFill>
+                  <a:srgbClr val="334155"/>
+                </a:solidFill>
+              </a:rPr>
+              <a:t>open CSV in Excel + printable report.</a:t>
+            </a:r>
+          </a:p>
+        </p:txBody>
+      </p:sp>
+      <p:sp>
+        <p:nvSpPr>
+          <p:cNvPr id="7" name="Rounded Rectangle 6"/>
+          <p:cNvSpPr/>
+          <p:nvPr/>
+        </p:nvSpPr>
+        <p:spPr>
+          <a:xfrm>
+            <a:off x="6217920" y="1371600"/>
+            <a:ext cx="5212080" cy="4937760"/>
+          </a:xfrm>
+          <a:prstGeom prst="roundRect">
+            <a:avLst/>
+          </a:prstGeom>
+          <a:solidFill>
+            <a:srgbClr val="FFFFFF"/>
+          </a:solidFill>
+          <a:ln w="12700">
+            <a:solidFill>
+              <a:srgbClr val="E2E8F0"/>
+            </a:solidFill>
+          </a:ln>
+        </p:spPr>
+        <p:style>
+          <a:lnRef idx="1">
+            <a:schemeClr val="accent1"/>
+          </a:lnRef>
+          <a:fillRef idx="3">
+            <a:schemeClr val="accent1"/>
+          </a:fillRef>
+          <a:effectRef idx="2">
+            <a:schemeClr val="accent1"/>
+          </a:effectRef>
+          <a:fontRef idx="minor">
+            <a:schemeClr val="lt1"/>
+          </a:fontRef>
+        </p:style>
+        <p:txBody>
+          <a:bodyPr rtlCol="0" anchor="ctr"/>
+          <a:lstStyle/>
+          <a:p>
+            <a:pPr algn="ctr"/>
+          </a:p>
+        </p:txBody>
+      </p:sp>
+      <p:sp>
+        <p:nvSpPr>
+          <p:cNvPr id="8" name="TextBox 7"/>
+          <p:cNvSpPr txBox="1"/>
+          <p:nvPr/>
+        </p:nvSpPr>
+        <p:spPr>
+          <a:xfrm>
+            <a:off x="6400800" y="1508760"/>
+            <a:ext cx="4846320" cy="411480"/>
+          </a:xfrm>
+          <a:prstGeom prst="rect">
+            <a:avLst/>
+          </a:prstGeom>
+          <a:noFill/>
+        </p:spPr>
+        <p:txBody>
+          <a:bodyPr wrap="none">
+            <a:spAutoFit/>
+          </a:bodyPr>
+          <a:lstStyle/>
+          <a:p>
+            <a:pPr>
+              <a:defRPr sz="1300" b="1">
+                <a:solidFill>
+                  <a:srgbClr val="0F172A"/>
+                </a:solidFill>
+              </a:defRPr>
+            </a:pPr>
+            <a:r>
+              <a:t>Anticipated Viva Q&amp;A</a:t>
+            </a:r>
+          </a:p>
+        </p:txBody>
+      </p:sp>
+      <p:sp>
+        <p:nvSpPr>
+          <p:cNvPr id="9" name="TextBox 8"/>
+          <p:cNvSpPr txBox="1"/>
+          <p:nvPr/>
+        </p:nvSpPr>
+        <p:spPr>
+          <a:xfrm>
+            <a:off x="6400800" y="1965960"/>
+            <a:ext cx="4846320" cy="4206240"/>
+          </a:xfrm>
+          <a:prstGeom prst="rect">
+            <a:avLst/>
+          </a:prstGeom>
+          <a:noFill/>
+        </p:spPr>
+        <p:txBody>
+          <a:bodyPr wrap="square">
+            <a:spAutoFit/>
+          </a:bodyPr>
+          <a:lstStyle/>
+          <a:p>
+            <a:pPr>
+              <a:spcAft>
+                <a:spcPts val="800"/>
+              </a:spcAft>
+              <a:defRPr b="1" sz="1100">
+                <a:solidFill>
+                  <a:srgbClr val="2563EB"/>
+                </a:solidFill>
+              </a:defRPr>
+            </a:pPr>
+            <a:r>
+              <a:t>Q: Single-file server? </a:t>
+            </a:r>
+            <a:r>
+              <a:rPr b="0">
+                <a:solidFill>
+                  <a:srgbClr val="334155"/>
+                </a:solidFill>
+              </a:rPr>
+              <a:t>Easy viva inspection of full lifecycle.</a:t>
+            </a:r>
+          </a:p>
+          <a:p>
+            <a:pPr>
+              <a:spcAft>
+                <a:spcPts val="800"/>
+              </a:spcAft>
+              <a:defRPr b="1" sz="1100">
+                <a:solidFill>
+                  <a:srgbClr val="2563EB"/>
+                </a:solidFill>
+              </a:defRPr>
+            </a:pPr>
+            <a:r>
+              <a:t>Q: Memory-first DB? </a:t>
+            </a:r>
+            <a:r>
+              <a:rPr b="0">
+                <a:solidFill>
+                  <a:srgbClr val="334155"/>
+                </a:solidFill>
+              </a:rPr>
+              <a:t>Demo-safe on any PC; Mongo via one env var.</a:t>
+            </a:r>
+          </a:p>
+          <a:p>
+            <a:pPr>
+              <a:spcAft>
+                <a:spcPts val="800"/>
+              </a:spcAft>
+              <a:defRPr b="1" sz="1100">
+                <a:solidFill>
+                  <a:srgbClr val="2563EB"/>
+                </a:solidFill>
+              </a:defRPr>
+            </a:pPr>
+            <a:r>
+              <a:t>Q: No Tailwind? </a:t>
+            </a:r>
+            <a:r>
+              <a:rPr b="0">
+                <a:solidFill>
+                  <a:srgbClr val="334155"/>
+                </a:solidFill>
+              </a:rPr>
+              <a:t>Zero-build; runs straight from disk.</a:t>
+            </a:r>
+          </a:p>
+          <a:p>
+            <a:pPr>
+              <a:spcAft>
+                <a:spcPts val="800"/>
+              </a:spcAft>
+              <a:defRPr b="1" sz="1100">
+                <a:solidFill>
+                  <a:srgbClr val="2563EB"/>
+                </a:solidFill>
+              </a:defRPr>
+            </a:pPr>
+            <a:r>
+              <a:t>Q: Duplicate race? </a:t>
+            </a:r>
+            <a:r>
+              <a:rPr b="0">
+                <a:solidFill>
+                  <a:srgbClr val="334155"/>
+                </a:solidFill>
+              </a:rPr>
+              <a:t>Atomic PS check before commit; 400 on clash.</a:t>
             </a:r>
           </a:p>
         </p:txBody>
@@ -3602,52 +6952,782 @@
       <p:grpSpPr/>
       <p:sp>
         <p:nvSpPr>
-          <p:cNvPr id="2" name="Title 1"/>
-          <p:cNvSpPr>
-            <a:spLocks noGrp="1"/>
-          </p:cNvSpPr>
-          <p:nvPr>
-            <p:ph type="title"/>
-          </p:nvPr>
-        </p:nvSpPr>
-        <p:spPr/>
-        <p:txBody>
-          <a:bodyPr/>
-          <a:lstStyle/>
-          <a:p>
-            <a:r>
-              <a:t>Conclusion</a:t>
-            </a:r>
-          </a:p>
-        </p:txBody>
-      </p:sp>
-      <p:sp>
-        <p:nvSpPr>
-          <p:cNvPr id="3" name="Content Placeholder 2"/>
-          <p:cNvSpPr>
-            <a:spLocks noGrp="1"/>
-          </p:cNvSpPr>
-          <p:nvPr>
-            <p:ph idx="1"/>
-          </p:nvPr>
-        </p:nvSpPr>
-        <p:spPr/>
-        <p:txBody>
-          <a:bodyPr/>
-          <a:lstStyle/>
-          <a:p>
-            <a:r>
-              <a:t>All 8 PBL features working.</a:t>
-            </a:r>
-          </a:p>
-          <a:p>
-            <a:r>
-              <a:t>Roles: lead integrated, frontend built UI, backend built APIs, QA tested + docs.</a:t>
-            </a:r>
-          </a:p>
-          <a:p>
-            <a:r>
-              <a:t>Next: real email, mentor login, auth.</a:t>
+          <p:cNvPr id="2" name="TextBox 1"/>
+          <p:cNvSpPr txBox="1"/>
+          <p:nvPr/>
+        </p:nvSpPr>
+        <p:spPr>
+          <a:xfrm>
+            <a:off x="731520" y="320040"/>
+            <a:ext cx="10698480" cy="320040"/>
+          </a:xfrm>
+          <a:prstGeom prst="rect">
+            <a:avLst/>
+          </a:prstGeom>
+          <a:noFill/>
+        </p:spPr>
+        <p:txBody>
+          <a:bodyPr wrap="none">
+            <a:spAutoFit/>
+          </a:bodyPr>
+          <a:lstStyle/>
+          <a:p>
+            <a:pPr>
+              <a:defRPr sz="1000" b="1">
+                <a:solidFill>
+                  <a:srgbClr val="2563EB"/>
+                </a:solidFill>
+              </a:defRPr>
+            </a:pPr>
+            <a:r>
+              <a:t>SIH COMMAND CENTER | PBL 14</a:t>
+            </a:r>
+          </a:p>
+        </p:txBody>
+      </p:sp>
+      <p:sp>
+        <p:nvSpPr>
+          <p:cNvPr id="3" name="TextBox 2"/>
+          <p:cNvSpPr txBox="1"/>
+          <p:nvPr/>
+        </p:nvSpPr>
+        <p:spPr>
+          <a:xfrm>
+            <a:off x="731520" y="621792"/>
+            <a:ext cx="10698480" cy="640080"/>
+          </a:xfrm>
+          <a:prstGeom prst="rect">
+            <a:avLst/>
+          </a:prstGeom>
+          <a:noFill/>
+        </p:spPr>
+        <p:txBody>
+          <a:bodyPr wrap="none">
+            <a:spAutoFit/>
+          </a:bodyPr>
+          <a:lstStyle/>
+          <a:p>
+            <a:pPr>
+              <a:defRPr sz="2200" b="1">
+                <a:solidFill>
+                  <a:srgbClr val="0F172A"/>
+                </a:solidFill>
+              </a:defRPr>
+            </a:pPr>
+            <a:r>
+              <a:t>Project Summary &amp; Engineering Contributions</a:t>
+            </a:r>
+          </a:p>
+        </p:txBody>
+      </p:sp>
+      <p:sp>
+        <p:nvSpPr>
+          <p:cNvPr id="4" name="Rounded Rectangle 3"/>
+          <p:cNvSpPr/>
+          <p:nvPr/>
+        </p:nvSpPr>
+        <p:spPr>
+          <a:xfrm>
+            <a:off x="731520" y="1371600"/>
+            <a:ext cx="2468880" cy="4937760"/>
+          </a:xfrm>
+          <a:prstGeom prst="roundRect">
+            <a:avLst/>
+          </a:prstGeom>
+          <a:solidFill>
+            <a:srgbClr val="FFFFFF"/>
+          </a:solidFill>
+          <a:ln w="12700">
+            <a:solidFill>
+              <a:srgbClr val="E2E8F0"/>
+            </a:solidFill>
+          </a:ln>
+        </p:spPr>
+        <p:style>
+          <a:lnRef idx="1">
+            <a:schemeClr val="accent1"/>
+          </a:lnRef>
+          <a:fillRef idx="3">
+            <a:schemeClr val="accent1"/>
+          </a:fillRef>
+          <a:effectRef idx="2">
+            <a:schemeClr val="accent1"/>
+          </a:effectRef>
+          <a:fontRef idx="minor">
+            <a:schemeClr val="lt1"/>
+          </a:fontRef>
+        </p:style>
+        <p:txBody>
+          <a:bodyPr rtlCol="0" anchor="ctr"/>
+          <a:lstStyle/>
+          <a:p>
+            <a:pPr algn="ctr"/>
+          </a:p>
+        </p:txBody>
+      </p:sp>
+      <p:sp>
+        <p:nvSpPr>
+          <p:cNvPr id="5" name="TextBox 4"/>
+          <p:cNvSpPr txBox="1"/>
+          <p:nvPr/>
+        </p:nvSpPr>
+        <p:spPr>
+          <a:xfrm>
+            <a:off x="914400" y="1508760"/>
+            <a:ext cx="2103120" cy="411480"/>
+          </a:xfrm>
+          <a:prstGeom prst="rect">
+            <a:avLst/>
+          </a:prstGeom>
+          <a:noFill/>
+        </p:spPr>
+        <p:txBody>
+          <a:bodyPr wrap="none">
+            <a:spAutoFit/>
+          </a:bodyPr>
+          <a:lstStyle/>
+          <a:p>
+            <a:pPr>
+              <a:defRPr sz="1300" b="1">
+                <a:solidFill>
+                  <a:srgbClr val="0F172A"/>
+                </a:solidFill>
+              </a:defRPr>
+            </a:pPr>
+            <a:r>
+              <a:t>Full-Stack / Integrator</a:t>
+            </a:r>
+          </a:p>
+        </p:txBody>
+      </p:sp>
+      <p:sp>
+        <p:nvSpPr>
+          <p:cNvPr id="6" name="TextBox 5"/>
+          <p:cNvSpPr txBox="1"/>
+          <p:nvPr/>
+        </p:nvSpPr>
+        <p:spPr>
+          <a:xfrm>
+            <a:off x="868680" y="1965960"/>
+            <a:ext cx="2194560" cy="4206240"/>
+          </a:xfrm>
+          <a:prstGeom prst="rect">
+            <a:avLst/>
+          </a:prstGeom>
+          <a:noFill/>
+        </p:spPr>
+        <p:txBody>
+          <a:bodyPr wrap="square">
+            <a:spAutoFit/>
+          </a:bodyPr>
+          <a:lstStyle/>
+          <a:p>
+            <a:pPr>
+              <a:spcAft>
+                <a:spcPts val="800"/>
+              </a:spcAft>
+              <a:defRPr sz="1300" b="1">
+                <a:solidFill>
+                  <a:srgbClr val="2563EB"/>
+                </a:solidFill>
+              </a:defRPr>
+            </a:pPr>
+            <a:r>
+              <a:t>You</a:t>
+            </a:r>
+          </a:p>
+          <a:p>
+            <a:pPr>
+              <a:spcAft>
+                <a:spcPts val="400"/>
+              </a:spcAft>
+              <a:defRPr sz="1000">
+                <a:solidFill>
+                  <a:srgbClr val="334155"/>
+                </a:solidFill>
+              </a:defRPr>
+            </a:pPr>
+            <a:r>
+              <a:t>- Core architecture &amp; integration</a:t>
+            </a:r>
+          </a:p>
+          <a:p>
+            <a:pPr>
+              <a:spcAft>
+                <a:spcPts val="400"/>
+              </a:spcAft>
+              <a:defRPr sz="1000">
+                <a:solidFill>
+                  <a:srgbClr val="334155"/>
+                </a:solidFill>
+              </a:defRPr>
+            </a:pPr>
+            <a:r>
+              <a:t>- Dashboard &amp; readiness logic</a:t>
+            </a:r>
+          </a:p>
+          <a:p>
+            <a:pPr>
+              <a:spcAft>
+                <a:spcPts val="400"/>
+              </a:spcAft>
+              <a:defRPr sz="1000">
+                <a:solidFill>
+                  <a:srgbClr val="334155"/>
+                </a:solidFill>
+              </a:defRPr>
+            </a:pPr>
+            <a:r>
+              <a:t>- API wiring &amp; hardening</a:t>
+            </a:r>
+          </a:p>
+          <a:p>
+            <a:pPr>
+              <a:spcAft>
+                <a:spcPts val="400"/>
+              </a:spcAft>
+              <a:defRPr sz="1000">
+                <a:solidFill>
+                  <a:srgbClr val="334155"/>
+                </a:solidFill>
+              </a:defRPr>
+            </a:pPr>
+            <a:r>
+              <a:t>- Deployment + live demo</a:t>
+            </a:r>
+          </a:p>
+        </p:txBody>
+      </p:sp>
+      <p:sp>
+        <p:nvSpPr>
+          <p:cNvPr id="7" name="Rounded Rectangle 6"/>
+          <p:cNvSpPr/>
+          <p:nvPr/>
+        </p:nvSpPr>
+        <p:spPr>
+          <a:xfrm>
+            <a:off x="3429000" y="1371600"/>
+            <a:ext cx="2468880" cy="4937760"/>
+          </a:xfrm>
+          <a:prstGeom prst="roundRect">
+            <a:avLst/>
+          </a:prstGeom>
+          <a:solidFill>
+            <a:srgbClr val="FFFFFF"/>
+          </a:solidFill>
+          <a:ln w="12700">
+            <a:solidFill>
+              <a:srgbClr val="E2E8F0"/>
+            </a:solidFill>
+          </a:ln>
+        </p:spPr>
+        <p:style>
+          <a:lnRef idx="1">
+            <a:schemeClr val="accent1"/>
+          </a:lnRef>
+          <a:fillRef idx="3">
+            <a:schemeClr val="accent1"/>
+          </a:fillRef>
+          <a:effectRef idx="2">
+            <a:schemeClr val="accent1"/>
+          </a:effectRef>
+          <a:fontRef idx="minor">
+            <a:schemeClr val="lt1"/>
+          </a:fontRef>
+        </p:style>
+        <p:txBody>
+          <a:bodyPr rtlCol="0" anchor="ctr"/>
+          <a:lstStyle/>
+          <a:p>
+            <a:pPr algn="ctr"/>
+          </a:p>
+        </p:txBody>
+      </p:sp>
+      <p:sp>
+        <p:nvSpPr>
+          <p:cNvPr id="8" name="TextBox 7"/>
+          <p:cNvSpPr txBox="1"/>
+          <p:nvPr/>
+        </p:nvSpPr>
+        <p:spPr>
+          <a:xfrm>
+            <a:off x="3611880" y="1508760"/>
+            <a:ext cx="2103120" cy="411480"/>
+          </a:xfrm>
+          <a:prstGeom prst="rect">
+            <a:avLst/>
+          </a:prstGeom>
+          <a:noFill/>
+        </p:spPr>
+        <p:txBody>
+          <a:bodyPr wrap="none">
+            <a:spAutoFit/>
+          </a:bodyPr>
+          <a:lstStyle/>
+          <a:p>
+            <a:pPr>
+              <a:defRPr sz="1300" b="1">
+                <a:solidFill>
+                  <a:srgbClr val="0F172A"/>
+                </a:solidFill>
+              </a:defRPr>
+            </a:pPr>
+            <a:r>
+              <a:t>Frontend Developer</a:t>
+            </a:r>
+          </a:p>
+        </p:txBody>
+      </p:sp>
+      <p:sp>
+        <p:nvSpPr>
+          <p:cNvPr id="9" name="TextBox 8"/>
+          <p:cNvSpPr txBox="1"/>
+          <p:nvPr/>
+        </p:nvSpPr>
+        <p:spPr>
+          <a:xfrm>
+            <a:off x="3566160" y="1965960"/>
+            <a:ext cx="2194560" cy="4206240"/>
+          </a:xfrm>
+          <a:prstGeom prst="rect">
+            <a:avLst/>
+          </a:prstGeom>
+          <a:noFill/>
+        </p:spPr>
+        <p:txBody>
+          <a:bodyPr wrap="square">
+            <a:spAutoFit/>
+          </a:bodyPr>
+          <a:lstStyle/>
+          <a:p>
+            <a:pPr>
+              <a:spcAft>
+                <a:spcPts val="800"/>
+              </a:spcAft>
+              <a:defRPr sz="1300" b="1">
+                <a:solidFill>
+                  <a:srgbClr val="2563EB"/>
+                </a:solidFill>
+              </a:defRPr>
+            </a:pPr>
+            <a:r>
+              <a:t>Member 2</a:t>
+            </a:r>
+          </a:p>
+          <a:p>
+            <a:pPr>
+              <a:spcAft>
+                <a:spcPts val="400"/>
+              </a:spcAft>
+              <a:defRPr sz="1000">
+                <a:solidFill>
+                  <a:srgbClr val="334155"/>
+                </a:solidFill>
+              </a:defRPr>
+            </a:pPr>
+            <a:r>
+              <a:t>- 5 responsive pages</a:t>
+            </a:r>
+          </a:p>
+          <a:p>
+            <a:pPr>
+              <a:spcAft>
+                <a:spcPts val="400"/>
+              </a:spcAft>
+              <a:defRPr sz="1000">
+                <a:solidFill>
+                  <a:srgbClr val="334155"/>
+                </a:solidFill>
+              </a:defRPr>
+            </a:pPr>
+            <a:r>
+              <a:t>- 3-step team wizard</a:t>
+            </a:r>
+          </a:p>
+          <a:p>
+            <a:pPr>
+              <a:spcAft>
+                <a:spcPts val="400"/>
+              </a:spcAft>
+              <a:defRPr sz="1000">
+                <a:solidFill>
+                  <a:srgbClr val="334155"/>
+                </a:solidFill>
+              </a:defRPr>
+            </a:pPr>
+            <a:r>
+              <a:t>- Mobile @390px CSS</a:t>
+            </a:r>
+          </a:p>
+          <a:p>
+            <a:pPr>
+              <a:spcAft>
+                <a:spcPts val="400"/>
+              </a:spcAft>
+              <a:defRPr sz="1000">
+                <a:solidFill>
+                  <a:srgbClr val="334155"/>
+                </a:solidFill>
+              </a:defRPr>
+            </a:pPr>
+            <a:r>
+              <a:t>- Validation + esc() UI</a:t>
+            </a:r>
+          </a:p>
+        </p:txBody>
+      </p:sp>
+      <p:sp>
+        <p:nvSpPr>
+          <p:cNvPr id="10" name="Rounded Rectangle 9"/>
+          <p:cNvSpPr/>
+          <p:nvPr/>
+        </p:nvSpPr>
+        <p:spPr>
+          <a:xfrm>
+            <a:off x="6126480" y="1371600"/>
+            <a:ext cx="2468880" cy="4937760"/>
+          </a:xfrm>
+          <a:prstGeom prst="roundRect">
+            <a:avLst/>
+          </a:prstGeom>
+          <a:solidFill>
+            <a:srgbClr val="FFFFFF"/>
+          </a:solidFill>
+          <a:ln w="12700">
+            <a:solidFill>
+              <a:srgbClr val="E2E8F0"/>
+            </a:solidFill>
+          </a:ln>
+        </p:spPr>
+        <p:style>
+          <a:lnRef idx="1">
+            <a:schemeClr val="accent1"/>
+          </a:lnRef>
+          <a:fillRef idx="3">
+            <a:schemeClr val="accent1"/>
+          </a:fillRef>
+          <a:effectRef idx="2">
+            <a:schemeClr val="accent1"/>
+          </a:effectRef>
+          <a:fontRef idx="minor">
+            <a:schemeClr val="lt1"/>
+          </a:fontRef>
+        </p:style>
+        <p:txBody>
+          <a:bodyPr rtlCol="0" anchor="ctr"/>
+          <a:lstStyle/>
+          <a:p>
+            <a:pPr algn="ctr"/>
+          </a:p>
+        </p:txBody>
+      </p:sp>
+      <p:sp>
+        <p:nvSpPr>
+          <p:cNvPr id="11" name="TextBox 10"/>
+          <p:cNvSpPr txBox="1"/>
+          <p:nvPr/>
+        </p:nvSpPr>
+        <p:spPr>
+          <a:xfrm>
+            <a:off x="6309360" y="1508760"/>
+            <a:ext cx="2103120" cy="411480"/>
+          </a:xfrm>
+          <a:prstGeom prst="rect">
+            <a:avLst/>
+          </a:prstGeom>
+          <a:noFill/>
+        </p:spPr>
+        <p:txBody>
+          <a:bodyPr wrap="none">
+            <a:spAutoFit/>
+          </a:bodyPr>
+          <a:lstStyle/>
+          <a:p>
+            <a:pPr>
+              <a:defRPr sz="1300" b="1">
+                <a:solidFill>
+                  <a:srgbClr val="0F172A"/>
+                </a:solidFill>
+              </a:defRPr>
+            </a:pPr>
+            <a:r>
+              <a:t>Backend Engineer</a:t>
+            </a:r>
+          </a:p>
+        </p:txBody>
+      </p:sp>
+      <p:sp>
+        <p:nvSpPr>
+          <p:cNvPr id="12" name="TextBox 11"/>
+          <p:cNvSpPr txBox="1"/>
+          <p:nvPr/>
+        </p:nvSpPr>
+        <p:spPr>
+          <a:xfrm>
+            <a:off x="6263640" y="1965960"/>
+            <a:ext cx="2194560" cy="4206240"/>
+          </a:xfrm>
+          <a:prstGeom prst="rect">
+            <a:avLst/>
+          </a:prstGeom>
+          <a:noFill/>
+        </p:spPr>
+        <p:txBody>
+          <a:bodyPr wrap="square">
+            <a:spAutoFit/>
+          </a:bodyPr>
+          <a:lstStyle/>
+          <a:p>
+            <a:pPr>
+              <a:spcAft>
+                <a:spcPts val="800"/>
+              </a:spcAft>
+              <a:defRPr sz="1300" b="1">
+                <a:solidFill>
+                  <a:srgbClr val="2563EB"/>
+                </a:solidFill>
+              </a:defRPr>
+            </a:pPr>
+            <a:r>
+              <a:t>Member 3</a:t>
+            </a:r>
+          </a:p>
+          <a:p>
+            <a:pPr>
+              <a:spcAft>
+                <a:spcPts val="400"/>
+              </a:spcAft>
+              <a:defRPr sz="1000">
+                <a:solidFill>
+                  <a:srgbClr val="334155"/>
+                </a:solidFill>
+              </a:defRPr>
+            </a:pPr>
+            <a:r>
+              <a:t>- 15 REST endpoints</a:t>
+            </a:r>
+          </a:p>
+          <a:p>
+            <a:pPr>
+              <a:spcAft>
+                <a:spcPts val="400"/>
+              </a:spcAft>
+              <a:defRPr sz="1000">
+                <a:solidFill>
+                  <a:srgbClr val="334155"/>
+                </a:solidFill>
+              </a:defRPr>
+            </a:pPr>
+            <a:r>
+              <a:t>- Mongoose dual-tier store</a:t>
+            </a:r>
+          </a:p>
+          <a:p>
+            <a:pPr>
+              <a:spcAft>
+                <a:spcPts val="400"/>
+              </a:spcAft>
+              <a:defRPr sz="1000">
+                <a:solidFill>
+                  <a:srgbClr val="334155"/>
+                </a:solidFill>
+              </a:defRPr>
+            </a:pPr>
+            <a:r>
+              <a:t>- SIH portal scraper</a:t>
+            </a:r>
+          </a:p>
+          <a:p>
+            <a:pPr>
+              <a:spcAft>
+                <a:spcPts val="400"/>
+              </a:spcAft>
+              <a:defRPr sz="1000">
+                <a:solidFill>
+                  <a:srgbClr val="334155"/>
+                </a:solidFill>
+              </a:defRPr>
+            </a:pPr>
+            <a:r>
+              <a:t>- CSV + report exports</a:t>
+            </a:r>
+          </a:p>
+        </p:txBody>
+      </p:sp>
+      <p:sp>
+        <p:nvSpPr>
+          <p:cNvPr id="13" name="Rounded Rectangle 12"/>
+          <p:cNvSpPr/>
+          <p:nvPr/>
+        </p:nvSpPr>
+        <p:spPr>
+          <a:xfrm>
+            <a:off x="8823960" y="1371600"/>
+            <a:ext cx="2468880" cy="4937760"/>
+          </a:xfrm>
+          <a:prstGeom prst="roundRect">
+            <a:avLst/>
+          </a:prstGeom>
+          <a:solidFill>
+            <a:srgbClr val="FFFFFF"/>
+          </a:solidFill>
+          <a:ln w="12700">
+            <a:solidFill>
+              <a:srgbClr val="E2E8F0"/>
+            </a:solidFill>
+          </a:ln>
+        </p:spPr>
+        <p:style>
+          <a:lnRef idx="1">
+            <a:schemeClr val="accent1"/>
+          </a:lnRef>
+          <a:fillRef idx="3">
+            <a:schemeClr val="accent1"/>
+          </a:fillRef>
+          <a:effectRef idx="2">
+            <a:schemeClr val="accent1"/>
+          </a:effectRef>
+          <a:fontRef idx="minor">
+            <a:schemeClr val="lt1"/>
+          </a:fontRef>
+        </p:style>
+        <p:txBody>
+          <a:bodyPr rtlCol="0" anchor="ctr"/>
+          <a:lstStyle/>
+          <a:p>
+            <a:pPr algn="ctr"/>
+          </a:p>
+        </p:txBody>
+      </p:sp>
+      <p:sp>
+        <p:nvSpPr>
+          <p:cNvPr id="14" name="TextBox 13"/>
+          <p:cNvSpPr txBox="1"/>
+          <p:nvPr/>
+        </p:nvSpPr>
+        <p:spPr>
+          <a:xfrm>
+            <a:off x="9006840" y="1508760"/>
+            <a:ext cx="2103120" cy="411480"/>
+          </a:xfrm>
+          <a:prstGeom prst="rect">
+            <a:avLst/>
+          </a:prstGeom>
+          <a:noFill/>
+        </p:spPr>
+        <p:txBody>
+          <a:bodyPr wrap="none">
+            <a:spAutoFit/>
+          </a:bodyPr>
+          <a:lstStyle/>
+          <a:p>
+            <a:pPr>
+              <a:defRPr sz="1300" b="1">
+                <a:solidFill>
+                  <a:srgbClr val="0F172A"/>
+                </a:solidFill>
+              </a:defRPr>
+            </a:pPr>
+            <a:r>
+              <a:t>QA &amp; Reliability Lead</a:t>
+            </a:r>
+          </a:p>
+        </p:txBody>
+      </p:sp>
+      <p:sp>
+        <p:nvSpPr>
+          <p:cNvPr id="15" name="TextBox 14"/>
+          <p:cNvSpPr txBox="1"/>
+          <p:nvPr/>
+        </p:nvSpPr>
+        <p:spPr>
+          <a:xfrm>
+            <a:off x="8961120" y="1965960"/>
+            <a:ext cx="2194560" cy="4206240"/>
+          </a:xfrm>
+          <a:prstGeom prst="rect">
+            <a:avLst/>
+          </a:prstGeom>
+          <a:noFill/>
+        </p:spPr>
+        <p:txBody>
+          <a:bodyPr wrap="square">
+            <a:spAutoFit/>
+          </a:bodyPr>
+          <a:lstStyle/>
+          <a:p>
+            <a:pPr>
+              <a:spcAft>
+                <a:spcPts val="800"/>
+              </a:spcAft>
+              <a:defRPr sz="1300" b="1">
+                <a:solidFill>
+                  <a:srgbClr val="2563EB"/>
+                </a:solidFill>
+              </a:defRPr>
+            </a:pPr>
+            <a:r>
+              <a:t>Member 4</a:t>
+            </a:r>
+          </a:p>
+          <a:p>
+            <a:pPr>
+              <a:spcAft>
+                <a:spcPts val="400"/>
+              </a:spcAft>
+              <a:defRPr sz="1000">
+                <a:solidFill>
+                  <a:srgbClr val="334155"/>
+                </a:solidFill>
+              </a:defRPr>
+            </a:pPr>
+            <a:r>
+              <a:t>- 105 automated cases</a:t>
+            </a:r>
+          </a:p>
+          <a:p>
+            <a:pPr>
+              <a:spcAft>
+                <a:spcPts val="400"/>
+              </a:spcAft>
+              <a:defRPr sz="1000">
+                <a:solidFill>
+                  <a:srgbClr val="334155"/>
+                </a:solidFill>
+              </a:defRPr>
+            </a:pPr>
+            <a:r>
+              <a:t>- Stress + browser suites</a:t>
+            </a:r>
+          </a:p>
+          <a:p>
+            <a:pPr>
+              <a:spcAft>
+                <a:spcPts val="400"/>
+              </a:spcAft>
+              <a:defRPr sz="1000">
+                <a:solidFill>
+                  <a:srgbClr val="334155"/>
+                </a:solidFill>
+              </a:defRPr>
+            </a:pPr>
+            <a:r>
+              <a:t>- DoS + XSS audit</a:t>
+            </a:r>
+          </a:p>
+          <a:p>
+            <a:pPr>
+              <a:spcAft>
+                <a:spcPts val="400"/>
+              </a:spcAft>
+              <a:defRPr sz="1000">
+                <a:solidFill>
+                  <a:srgbClr val="334155"/>
+                </a:solidFill>
+              </a:defRPr>
+            </a:pPr>
+            <a:r>
+              <a:t>- PPT + viva kit</a:t>
             </a:r>
           </a:p>
         </p:txBody>

</xml_diff>